<commit_message>
Banca 2: força da evidência por regra na cadeia, universos de candidatos explícitos e registro dos slides EXEMPLO ocultos
- cadeia_resumo_doc57: categoria de cada linha sai de forca_da_linha
  (Holm/IC/pré do Wald/estatuto do bloco) sobre valores registrados;
  P4 passa a "ATT sob tendências paralelas" (pré p 0,310; M̄ = 1,30).
- Tabela descritiva: linhas com universo explícito (G1, ligados ao CNES,
  1ª opção numa célula, amostra P1) e nota; códigos D_C*_P1 do P1_resumo.
- 02 e README: slides EXEMPLO 32/33 ocultos por decisão do agente,
  aguardando confirmação do grupo.
- Testes: regra de força recomputada e encaixe dos universos.

Co-Authored-By: Claude Opus 5.5 <noreply@anthropic.com>
Claude-Session: https://claude.ai/code/session_011jPV4G6BtUxSX71P3Fzkr7
</commit_message>
<xml_diff>
--- a/output/apresentacao_banca2/slides_empiricos_banca2.pptx
+++ b/output/apresentacao_banca2/slides_empiricos_banca2.pptx
@@ -8987,7 +8987,7 @@
           <a:p>
             <a:r>
               <a:rPr lang="pt-BR" dirty="0"/>
-              <a:t>O ciclo 2 abriu mais vagas imediatas e preencheu uma fração maior das células; o ciclo 3 tem muito cadastro reserva. A ligação ao CNES passa de nove em cada dez candidatos em todos os ciclos. Ciclo 3: só a 1ª chamada; o seguimento pós-início segue congelado. Cautela: Descritivo: as diferenças entre ciclos não são efeito da bolsa.</a:t>
+              <a:t>O ciclo 2 abriu mais vagas imediatas e preencheu uma fração maior das células; o ciclo 3 tem muito cadastro reserva. A ligação ao CNES passa de nove em cada dez candidatos em todos os ciclos. Se perguntarem pelos universos: o G1 conta todos os candidatos dos resultados; nos ciclos 2 e 3 alguns não têm a 1ª opção numa célula do quadro da 1ª chamada e ficam fora da escolha. A amostra do P1 soma 5.421 candidatos. Ciclo 3: só a 1ª chamada; o seguimento pós-início segue congelado. Cautela: Descritivo: as diferenças entre ciclos não são efeito da bolsa.</a:t>
             </a:r>
           </a:p>
         </p:txBody>
@@ -9459,7 +9459,7 @@
           <a:p>
             <a:r>
               <a:rPr lang="pt-BR" dirty="0"/>
-              <a:t>Ler de cima para baixo, na ordem da cadeia. Cinza: o IC contém o nulo. Verde em N1 é negativo e não passa no Holm. Verde em P6 Y1 é quase mecânico. Verde em P4 é associação com tendências paralelas. A escolha no ciclo 2 aparece no slide da H2. Cautela: Nenhuma pergunta tem hoje evidência causal limpa de mudança no resultado medido.</a:t>
+              <a:t>Ler de cima para baixo, na ordem da cadeia. Cinza: o IC contém o nulo. Verde em N1 é negativo e não passa no Holm. Verde em P6 Y1 é quase mecânico. Verde em P4 é associação: nas horas totais o pré passa e a conclusão aguenta violações de tendência do tamanho das do pré, mas outros outcomes do P4 falham no pré. A força de cada linha sai de uma regra fixa do gerador sobre os valores de output/. A escolha no ciclo 2 aparece no slide da H2. Cautela: Nenhuma pergunta tem hoje evidência causal limpa de mudança no resultado medido.</a:t>
             </a:r>
           </a:p>
         </p:txBody>
@@ -22593,19 +22593,19 @@
         </p:nvGraphicFramePr>
         <p:xfrm>
           <a:off x="292608" y="804672"/>
-          <a:ext cx="11594592" cy="3156712"/>
+          <a:ext cx="11594592" cy="3081782"/>
         </p:xfrm>
         <a:graphic>
           <a:graphicData uri="http://schemas.openxmlformats.org/drawingml/2006/table">
             <a:tbl>
               <a:tblPr firstRow="1" bandRow="1"/>
               <a:tblGrid>
-                <a:gridCol w="4795555"/>
-                <a:gridCol w="1873880"/>
-                <a:gridCol w="1926623"/>
-                <a:gridCol w="2998535"/>
+                <a:gridCol w="4890887"/>
+                <a:gridCol w="1832260"/>
+                <a:gridCol w="1888402"/>
+                <a:gridCol w="2983043"/>
               </a:tblGrid>
-              <a:tr h="326644">
+              <a:tr h="280162">
                 <a:tc>
                   <a:txBody>
                     <a:bodyPr/>
@@ -22624,7 +22624,7 @@
                         <a:buNone/>
                       </a:pPr>
                       <a:r>
-                        <a:rPr lang="pt-BR" sz="1400" b="1" dirty="0">
+                        <a:rPr lang="pt-BR" sz="1100" b="1" dirty="0">
                           <a:solidFill>
                             <a:srgbClr val="FFFFFF"/>
                           </a:solidFill>
@@ -22678,7 +22678,7 @@
                         <a:buNone/>
                       </a:pPr>
                       <a:r>
-                        <a:rPr lang="pt-BR" sz="1400" b="1" dirty="0">
+                        <a:rPr lang="pt-BR" sz="1100" b="1" dirty="0">
                           <a:solidFill>
                             <a:srgbClr val="FFFFFF"/>
                           </a:solidFill>
@@ -22732,7 +22732,7 @@
                         <a:buNone/>
                       </a:pPr>
                       <a:r>
-                        <a:rPr lang="pt-BR" sz="1400" b="1" dirty="0">
+                        <a:rPr lang="pt-BR" sz="1100" b="1" dirty="0">
                           <a:solidFill>
                             <a:srgbClr val="FFFFFF"/>
                           </a:solidFill>
@@ -22786,7 +22786,7 @@
                         <a:buNone/>
                       </a:pPr>
                       <a:r>
-                        <a:rPr lang="pt-BR" sz="1400" b="1" dirty="0">
+                        <a:rPr lang="pt-BR" sz="1100" b="1" dirty="0">
                           <a:solidFill>
                             <a:srgbClr val="FFFFFF"/>
                           </a:solidFill>
@@ -22823,7 +22823,7 @@
                   </a:tcPr>
                 </a:tc>
               </a:tr>
-              <a:tr h="326644">
+              <a:tr h="280162">
                 <a:tc>
                   <a:txBody>
                     <a:bodyPr/>
@@ -22842,7 +22842,7 @@
                         <a:buNone/>
                       </a:pPr>
                       <a:r>
-                        <a:rPr lang="pt-BR" sz="1400" b="1" dirty="0">
+                        <a:rPr lang="pt-BR" sz="1100" b="1" dirty="0">
                           <a:solidFill>
                             <a:srgbClr val="3A3A3A"/>
                           </a:solidFill>
@@ -22896,7 +22896,7 @@
                         <a:buNone/>
                       </a:pPr>
                       <a:r>
-                        <a:rPr lang="pt-BR" sz="1400" b="0" dirty="0">
+                        <a:rPr lang="pt-BR" sz="1100" b="0" dirty="0">
                           <a:solidFill>
                             <a:srgbClr val="3A3A3A"/>
                           </a:solidFill>
@@ -22950,7 +22950,7 @@
                         <a:buNone/>
                       </a:pPr>
                       <a:r>
-                        <a:rPr lang="pt-BR" sz="1400" b="0" dirty="0">
+                        <a:rPr lang="pt-BR" sz="1100" b="0" dirty="0">
                           <a:solidFill>
                             <a:srgbClr val="3A3A3A"/>
                           </a:solidFill>
@@ -23004,7 +23004,7 @@
                         <a:buNone/>
                       </a:pPr>
                       <a:r>
-                        <a:rPr lang="pt-BR" sz="1400" b="0" dirty="0">
+                        <a:rPr lang="pt-BR" sz="1100" b="0" dirty="0">
                           <a:solidFill>
                             <a:srgbClr val="3A3A3A"/>
                           </a:solidFill>
@@ -23041,7 +23041,7 @@
                   </a:tcPr>
                 </a:tc>
               </a:tr>
-              <a:tr h="326644">
+              <a:tr h="280162">
                 <a:tc>
                   <a:txBody>
                     <a:bodyPr/>
@@ -23060,7 +23060,7 @@
                         <a:buNone/>
                       </a:pPr>
                       <a:r>
-                        <a:rPr lang="pt-BR" sz="1400" b="1" dirty="0">
+                        <a:rPr lang="pt-BR" sz="1100" b="1" dirty="0">
                           <a:solidFill>
                             <a:srgbClr val="3A3A3A"/>
                           </a:solidFill>
@@ -23114,7 +23114,7 @@
                         <a:buNone/>
                       </a:pPr>
                       <a:r>
-                        <a:rPr lang="pt-BR" sz="1400" b="0" dirty="0">
+                        <a:rPr lang="pt-BR" sz="1100" b="0" dirty="0">
                           <a:solidFill>
                             <a:srgbClr val="3A3A3A"/>
                           </a:solidFill>
@@ -23168,7 +23168,7 @@
                         <a:buNone/>
                       </a:pPr>
                       <a:r>
-                        <a:rPr lang="pt-BR" sz="1400" b="0" dirty="0">
+                        <a:rPr lang="pt-BR" sz="1100" b="0" dirty="0">
                           <a:solidFill>
                             <a:srgbClr val="3A3A3A"/>
                           </a:solidFill>
@@ -23222,7 +23222,7 @@
                         <a:buNone/>
                       </a:pPr>
                       <a:r>
-                        <a:rPr lang="pt-BR" sz="1400" b="0" dirty="0">
+                        <a:rPr lang="pt-BR" sz="1100" b="0" dirty="0">
                           <a:solidFill>
                             <a:srgbClr val="3A3A3A"/>
                           </a:solidFill>
@@ -23259,7 +23259,7 @@
                   </a:tcPr>
                 </a:tc>
               </a:tr>
-              <a:tr h="326644">
+              <a:tr h="280162">
                 <a:tc>
                   <a:txBody>
                     <a:bodyPr/>
@@ -23278,7 +23278,7 @@
                         <a:buNone/>
                       </a:pPr>
                       <a:r>
-                        <a:rPr lang="pt-BR" sz="1400" b="1" dirty="0">
+                        <a:rPr lang="pt-BR" sz="1100" b="1" dirty="0">
                           <a:solidFill>
                             <a:srgbClr val="3A3A3A"/>
                           </a:solidFill>
@@ -23332,7 +23332,7 @@
                         <a:buNone/>
                       </a:pPr>
                       <a:r>
-                        <a:rPr lang="pt-BR" sz="1400" b="0" dirty="0">
+                        <a:rPr lang="pt-BR" sz="1100" b="0" dirty="0">
                           <a:solidFill>
                             <a:srgbClr val="3A3A3A"/>
                           </a:solidFill>
@@ -23386,7 +23386,7 @@
                         <a:buNone/>
                       </a:pPr>
                       <a:r>
-                        <a:rPr lang="pt-BR" sz="1400" b="0" dirty="0">
+                        <a:rPr lang="pt-BR" sz="1100" b="0" dirty="0">
                           <a:solidFill>
                             <a:srgbClr val="3A3A3A"/>
                           </a:solidFill>
@@ -23440,7 +23440,7 @@
                         <a:buNone/>
                       </a:pPr>
                       <a:r>
-                        <a:rPr lang="pt-BR" sz="1400" b="0" dirty="0">
+                        <a:rPr lang="pt-BR" sz="1100" b="0" dirty="0">
                           <a:solidFill>
                             <a:srgbClr val="3A3A3A"/>
                           </a:solidFill>
@@ -23477,7 +23477,7 @@
                   </a:tcPr>
                 </a:tc>
               </a:tr>
-              <a:tr h="326644">
+              <a:tr h="280162">
                 <a:tc>
                   <a:txBody>
                     <a:bodyPr/>
@@ -23496,13 +23496,13 @@
                         <a:buNone/>
                       </a:pPr>
                       <a:r>
-                        <a:rPr lang="pt-BR" sz="1400" b="1" dirty="0">
+                        <a:rPr lang="pt-BR" sz="1100" b="1" dirty="0">
                           <a:solidFill>
                             <a:srgbClr val="3A3A3A"/>
                           </a:solidFill>
                           <a:latin typeface="Montserrat"/>
                         </a:rPr>
-                        <a:t>Candidatos de 1ª opção numa célula</a:t>
+                        <a:t>Candidatos nos resultados (universo G1)</a:t>
                       </a:r>
                     </a:p>
                   </a:txBody>
@@ -23550,7 +23550,7 @@
                         <a:buNone/>
                       </a:pPr>
                       <a:r>
-                        <a:rPr lang="pt-BR" sz="1400" b="0" dirty="0">
+                        <a:rPr lang="pt-BR" sz="1100" b="0" dirty="0">
                           <a:solidFill>
                             <a:srgbClr val="3A3A3A"/>
                           </a:solidFill>
@@ -23604,13 +23604,13 @@
                         <a:buNone/>
                       </a:pPr>
                       <a:r>
-                        <a:rPr lang="pt-BR" sz="1400" b="0" dirty="0">
+                        <a:rPr lang="pt-BR" sz="1100" b="0" dirty="0">
                           <a:solidFill>
                             <a:srgbClr val="3A3A3A"/>
                           </a:solidFill>
                           <a:latin typeface="Montserrat"/>
                         </a:rPr>
-                        <a:t>2.140</a:t>
+                        <a:t>2.179</a:t>
                       </a:r>
                     </a:p>
                   </a:txBody>
@@ -23658,13 +23658,13 @@
                         <a:buNone/>
                       </a:pPr>
                       <a:r>
-                        <a:rPr lang="pt-BR" sz="1400" b="0" dirty="0">
+                        <a:rPr lang="pt-BR" sz="1100" b="0" dirty="0">
                           <a:solidFill>
                             <a:srgbClr val="3A3A3A"/>
                           </a:solidFill>
                           <a:latin typeface="Montserrat"/>
                         </a:rPr>
-                        <a:t>2.581</a:t>
+                        <a:t>2.604</a:t>
                       </a:r>
                     </a:p>
                   </a:txBody>
@@ -23695,7 +23695,7 @@
                   </a:tcPr>
                 </a:tc>
               </a:tr>
-              <a:tr h="326644">
+              <a:tr h="280162">
                 <a:tc>
                   <a:txBody>
                     <a:bodyPr/>
@@ -23714,13 +23714,13 @@
                         <a:buNone/>
                       </a:pPr>
                       <a:r>
-                        <a:rPr lang="pt-BR" sz="1400" b="1" dirty="0">
+                        <a:rPr lang="pt-BR" sz="1100" b="1" dirty="0">
                           <a:solidFill>
                             <a:srgbClr val="3A3A3A"/>
                           </a:solidFill>
                           <a:latin typeface="Montserrat"/>
                         </a:rPr>
-                        <a:t>Candidatos ligados ao CNES (G1)</a:t>
+                        <a:t>… ligados ao CNES</a:t>
                       </a:r>
                     </a:p>
                   </a:txBody>
@@ -23768,13 +23768,13 @@
                         <a:buNone/>
                       </a:pPr>
                       <a:r>
-                        <a:rPr lang="pt-BR" sz="1400" b="0" dirty="0">
+                        <a:rPr lang="pt-BR" sz="1100" b="0" dirty="0">
                           <a:solidFill>
                             <a:srgbClr val="3A3A3A"/>
                           </a:solidFill>
                           <a:latin typeface="Montserrat"/>
                         </a:rPr>
-                        <a:t>938 de 993</a:t>
+                        <a:t>938</a:t>
                       </a:r>
                     </a:p>
                   </a:txBody>
@@ -23822,13 +23822,13 @@
                         <a:buNone/>
                       </a:pPr>
                       <a:r>
-                        <a:rPr lang="pt-BR" sz="1400" b="0" dirty="0">
+                        <a:rPr lang="pt-BR" sz="1100" b="0" dirty="0">
                           <a:solidFill>
                             <a:srgbClr val="3A3A3A"/>
                           </a:solidFill>
                           <a:latin typeface="Montserrat"/>
                         </a:rPr>
-                        <a:t>2.102 de 2.179</a:t>
+                        <a:t>2.102</a:t>
                       </a:r>
                     </a:p>
                   </a:txBody>
@@ -23876,13 +23876,13 @@
                         <a:buNone/>
                       </a:pPr>
                       <a:r>
-                        <a:rPr lang="pt-BR" sz="1400" b="0" dirty="0">
+                        <a:rPr lang="pt-BR" sz="1100" b="0" dirty="0">
                           <a:solidFill>
                             <a:srgbClr val="3A3A3A"/>
                           </a:solidFill>
                           <a:latin typeface="Montserrat"/>
                         </a:rPr>
-                        <a:t>2.533 de 2.604</a:t>
+                        <a:t>2.533</a:t>
                       </a:r>
                     </a:p>
                   </a:txBody>
@@ -23913,7 +23913,7 @@
                   </a:tcPr>
                 </a:tc>
               </a:tr>
-              <a:tr h="326644">
+              <a:tr h="280162">
                 <a:tc>
                   <a:txBody>
                     <a:bodyPr/>
@@ -23932,13 +23932,13 @@
                         <a:buNone/>
                       </a:pPr>
                       <a:r>
-                        <a:rPr lang="pt-BR" sz="1400" b="1" dirty="0">
+                        <a:rPr lang="pt-BR" sz="1100" b="1" dirty="0">
                           <a:solidFill>
                             <a:srgbClr val="3A3A3A"/>
                           </a:solidFill>
                           <a:latin typeface="Montserrat"/>
                         </a:rPr>
-                        <a:t>Células preenchidas na 1ª chamada</a:t>
+                        <a:t>… com 1ª opção numa célula do quadro</a:t>
                       </a:r>
                     </a:p>
                   </a:txBody>
@@ -23986,13 +23986,13 @@
                         <a:buNone/>
                       </a:pPr>
                       <a:r>
-                        <a:rPr lang="pt-BR" sz="1400" b="0" dirty="0">
+                        <a:rPr lang="pt-BR" sz="1100" b="0" dirty="0">
                           <a:solidFill>
                             <a:srgbClr val="3A3A3A"/>
                           </a:solidFill>
                           <a:latin typeface="Montserrat"/>
                         </a:rPr>
-                        <a:t>393 (30,3%)</a:t>
+                        <a:t>993</a:t>
                       </a:r>
                     </a:p>
                   </a:txBody>
@@ -24040,13 +24040,13 @@
                         <a:buNone/>
                       </a:pPr>
                       <a:r>
-                        <a:rPr lang="pt-BR" sz="1400" b="0" dirty="0">
+                        <a:rPr lang="pt-BR" sz="1100" b="0" dirty="0">
                           <a:solidFill>
                             <a:srgbClr val="3A3A3A"/>
                           </a:solidFill>
                           <a:latin typeface="Montserrat"/>
                         </a:rPr>
-                        <a:t>728 (47,1%)</a:t>
+                        <a:t>2.140</a:t>
                       </a:r>
                     </a:p>
                   </a:txBody>
@@ -24094,13 +24094,13 @@
                         <a:buNone/>
                       </a:pPr>
                       <a:r>
-                        <a:rPr lang="pt-BR" sz="1400" b="0" dirty="0">
+                        <a:rPr lang="pt-BR" sz="1100" b="0" dirty="0">
                           <a:solidFill>
                             <a:srgbClr val="3A3A3A"/>
                           </a:solidFill>
                           <a:latin typeface="Montserrat"/>
                         </a:rPr>
-                        <a:t>497 (21,7%)</a:t>
+                        <a:t>2.581</a:t>
                       </a:r>
                     </a:p>
                   </a:txBody>
@@ -24131,7 +24131,7 @@
                   </a:tcPr>
                 </a:tc>
               </a:tr>
-              <a:tr h="326644">
+              <a:tr h="280162">
                 <a:tc>
                   <a:txBody>
                     <a:bodyPr/>
@@ -24150,13 +24150,13 @@
                         <a:buNone/>
                       </a:pPr>
                       <a:r>
-                        <a:rPr lang="pt-BR" sz="1400" b="1" dirty="0">
+                        <a:rPr lang="pt-BR" sz="1100" b="1" dirty="0">
                           <a:solidFill>
                             <a:srgbClr val="3A3A3A"/>
                           </a:solidFill>
                           <a:latin typeface="Montserrat"/>
                         </a:rPr>
-                        <a:t>Células preenchidas até a 2ª chamada</a:t>
+                        <a:t>Amostra da escolha (P1)</a:t>
                       </a:r>
                     </a:p>
                   </a:txBody>
@@ -24204,13 +24204,13 @@
                         <a:buNone/>
                       </a:pPr>
                       <a:r>
-                        <a:rPr lang="pt-BR" sz="1400" b="0" dirty="0">
+                        <a:rPr lang="pt-BR" sz="1100" b="0" dirty="0">
                           <a:solidFill>
                             <a:srgbClr val="3A3A3A"/>
                           </a:solidFill>
                           <a:latin typeface="Montserrat"/>
                         </a:rPr>
-                        <a:t>461 (35,6%)</a:t>
+                        <a:t>915</a:t>
                       </a:r>
                     </a:p>
                   </a:txBody>
@@ -24258,13 +24258,13 @@
                         <a:buNone/>
                       </a:pPr>
                       <a:r>
-                        <a:rPr lang="pt-BR" sz="1400" b="0" dirty="0">
+                        <a:rPr lang="pt-BR" sz="1100" b="0" dirty="0">
                           <a:solidFill>
                             <a:srgbClr val="3A3A3A"/>
                           </a:solidFill>
                           <a:latin typeface="Montserrat"/>
                         </a:rPr>
-                        <a:t>867 (56,0%)</a:t>
+                        <a:t>2.032</a:t>
                       </a:r>
                     </a:p>
                   </a:txBody>
@@ -24312,13 +24312,13 @@
                         <a:buNone/>
                       </a:pPr>
                       <a:r>
-                        <a:rPr lang="pt-BR" sz="1400" b="0" dirty="0">
+                        <a:rPr lang="pt-BR" sz="1100" b="0" dirty="0">
                           <a:solidFill>
                             <a:srgbClr val="3A3A3A"/>
                           </a:solidFill>
                           <a:latin typeface="Montserrat"/>
                         </a:rPr>
-                        <a:t>não observado</a:t>
+                        <a:t>2.474</a:t>
                       </a:r>
                     </a:p>
                   </a:txBody>
@@ -24349,7 +24349,7 @@
                   </a:tcPr>
                 </a:tc>
               </a:tr>
-              <a:tr h="543560">
+              <a:tr h="280162">
                 <a:tc>
                   <a:txBody>
                     <a:bodyPr/>
@@ -24368,13 +24368,13 @@
                         <a:buNone/>
                       </a:pPr>
                       <a:r>
-                        <a:rPr lang="pt-BR" sz="1400" b="1" dirty="0">
+                        <a:rPr lang="pt-BR" sz="1100" b="1" dirty="0">
                           <a:solidFill>
                             <a:srgbClr val="3A3A3A"/>
                           </a:solidFill>
                           <a:latin typeface="Montserrat"/>
                         </a:rPr>
-                        <a:t>Municípios por faixa: R$ 10 · 15 · 20 mil</a:t>
+                        <a:t>Células preenchidas na 1ª chamada</a:t>
                       </a:r>
                     </a:p>
                   </a:txBody>
@@ -24422,13 +24422,13 @@
                         <a:buNone/>
                       </a:pPr>
                       <a:r>
-                        <a:rPr lang="pt-BR" sz="1400" b="0" dirty="0">
+                        <a:rPr lang="pt-BR" sz="1100" b="0" dirty="0">
                           <a:solidFill>
                             <a:srgbClr val="3A3A3A"/>
                           </a:solidFill>
                           <a:latin typeface="Montserrat"/>
                         </a:rPr>
-                        <a:t>159 · 107 · 102</a:t>
+                        <a:t>393 (30,3%)</a:t>
                       </a:r>
                     </a:p>
                   </a:txBody>
@@ -24476,13 +24476,13 @@
                         <a:buNone/>
                       </a:pPr>
                       <a:r>
-                        <a:rPr lang="pt-BR" sz="1400" b="0" dirty="0">
+                        <a:rPr lang="pt-BR" sz="1100" b="0" dirty="0">
                           <a:solidFill>
                             <a:srgbClr val="3A3A3A"/>
                           </a:solidFill>
                           <a:latin typeface="Montserrat"/>
                         </a:rPr>
-                        <a:t>210 · 115 · 129</a:t>
+                        <a:t>728 (47,1%)</a:t>
                       </a:r>
                     </a:p>
                   </a:txBody>
@@ -24530,7 +24530,443 @@
                         <a:buNone/>
                       </a:pPr>
                       <a:r>
-                        <a:rPr lang="pt-BR" sz="1400" b="0" dirty="0">
+                        <a:rPr lang="pt-BR" sz="1100" b="0" dirty="0">
+                          <a:solidFill>
+                            <a:srgbClr val="3A3A3A"/>
+                          </a:solidFill>
+                          <a:latin typeface="Montserrat"/>
+                        </a:rPr>
+                        <a:t>497 (21,7%)</a:t>
+                      </a:r>
+                    </a:p>
+                  </a:txBody>
+                  <a:tcPr marL="64008" marR="64008" marT="36576" marB="36576" anchor="ctr">
+                    <a:lnL w="6350">
+                      <a:solidFill>
+                        <a:srgbClr val="C9DED1"/>
+                      </a:solidFill>
+                    </a:lnL>
+                    <a:lnR w="6350">
+                      <a:solidFill>
+                        <a:srgbClr val="C9DED1"/>
+                      </a:solidFill>
+                    </a:lnR>
+                    <a:lnT w="6350">
+                      <a:solidFill>
+                        <a:srgbClr val="C9DED1"/>
+                      </a:solidFill>
+                    </a:lnT>
+                    <a:lnB w="6350">
+                      <a:solidFill>
+                        <a:srgbClr val="C9DED1"/>
+                      </a:solidFill>
+                    </a:lnB>
+                    <a:solidFill>
+                      <a:srgbClr val="FFFFFF"/>
+                    </a:solidFill>
+                  </a:tcPr>
+                </a:tc>
+              </a:tr>
+              <a:tr h="280162">
+                <a:tc>
+                  <a:txBody>
+                    <a:bodyPr/>
+                    <a:lstStyle/>
+                    <a:p>
+                      <a:pPr marL="0" indent="0" algn="l">
+                        <a:lnSpc>
+                          <a:spcPct val="100000"/>
+                        </a:lnSpc>
+                        <a:spcBef>
+                          <a:spcPts val="0"/>
+                        </a:spcBef>
+                        <a:spcAft>
+                          <a:spcPts val="0"/>
+                        </a:spcAft>
+                        <a:buNone/>
+                      </a:pPr>
+                      <a:r>
+                        <a:rPr lang="pt-BR" sz="1100" b="1" dirty="0">
+                          <a:solidFill>
+                            <a:srgbClr val="3A3A3A"/>
+                          </a:solidFill>
+                          <a:latin typeface="Montserrat"/>
+                        </a:rPr>
+                        <a:t>Células preenchidas até a 2ª chamada</a:t>
+                      </a:r>
+                    </a:p>
+                  </a:txBody>
+                  <a:tcPr marL="64008" marR="64008" marT="36576" marB="36576" anchor="ctr">
+                    <a:lnL w="6350">
+                      <a:solidFill>
+                        <a:srgbClr val="C9DED1"/>
+                      </a:solidFill>
+                    </a:lnL>
+                    <a:lnR w="6350">
+                      <a:solidFill>
+                        <a:srgbClr val="C9DED1"/>
+                      </a:solidFill>
+                    </a:lnR>
+                    <a:lnT w="6350">
+                      <a:solidFill>
+                        <a:srgbClr val="C9DED1"/>
+                      </a:solidFill>
+                    </a:lnT>
+                    <a:lnB w="6350">
+                      <a:solidFill>
+                        <a:srgbClr val="C9DED1"/>
+                      </a:solidFill>
+                    </a:lnB>
+                    <a:solidFill>
+                      <a:srgbClr val="F3F7F3"/>
+                    </a:solidFill>
+                  </a:tcPr>
+                </a:tc>
+                <a:tc>
+                  <a:txBody>
+                    <a:bodyPr/>
+                    <a:lstStyle/>
+                    <a:p>
+                      <a:pPr marL="0" indent="0" algn="l">
+                        <a:lnSpc>
+                          <a:spcPct val="100000"/>
+                        </a:lnSpc>
+                        <a:spcBef>
+                          <a:spcPts val="0"/>
+                        </a:spcBef>
+                        <a:spcAft>
+                          <a:spcPts val="0"/>
+                        </a:spcAft>
+                        <a:buNone/>
+                      </a:pPr>
+                      <a:r>
+                        <a:rPr lang="pt-BR" sz="1100" b="0" dirty="0">
+                          <a:solidFill>
+                            <a:srgbClr val="3A3A3A"/>
+                          </a:solidFill>
+                          <a:latin typeface="Montserrat"/>
+                        </a:rPr>
+                        <a:t>461 (35,6%)</a:t>
+                      </a:r>
+                    </a:p>
+                  </a:txBody>
+                  <a:tcPr marL="64008" marR="64008" marT="36576" marB="36576" anchor="ctr">
+                    <a:lnL w="6350">
+                      <a:solidFill>
+                        <a:srgbClr val="C9DED1"/>
+                      </a:solidFill>
+                    </a:lnL>
+                    <a:lnR w="6350">
+                      <a:solidFill>
+                        <a:srgbClr val="C9DED1"/>
+                      </a:solidFill>
+                    </a:lnR>
+                    <a:lnT w="6350">
+                      <a:solidFill>
+                        <a:srgbClr val="C9DED1"/>
+                      </a:solidFill>
+                    </a:lnT>
+                    <a:lnB w="6350">
+                      <a:solidFill>
+                        <a:srgbClr val="C9DED1"/>
+                      </a:solidFill>
+                    </a:lnB>
+                    <a:solidFill>
+                      <a:srgbClr val="F3F7F3"/>
+                    </a:solidFill>
+                  </a:tcPr>
+                </a:tc>
+                <a:tc>
+                  <a:txBody>
+                    <a:bodyPr/>
+                    <a:lstStyle/>
+                    <a:p>
+                      <a:pPr marL="0" indent="0" algn="l">
+                        <a:lnSpc>
+                          <a:spcPct val="100000"/>
+                        </a:lnSpc>
+                        <a:spcBef>
+                          <a:spcPts val="0"/>
+                        </a:spcBef>
+                        <a:spcAft>
+                          <a:spcPts val="0"/>
+                        </a:spcAft>
+                        <a:buNone/>
+                      </a:pPr>
+                      <a:r>
+                        <a:rPr lang="pt-BR" sz="1100" b="0" dirty="0">
+                          <a:solidFill>
+                            <a:srgbClr val="3A3A3A"/>
+                          </a:solidFill>
+                          <a:latin typeface="Montserrat"/>
+                        </a:rPr>
+                        <a:t>867 (56,0%)</a:t>
+                      </a:r>
+                    </a:p>
+                  </a:txBody>
+                  <a:tcPr marL="64008" marR="64008" marT="36576" marB="36576" anchor="ctr">
+                    <a:lnL w="6350">
+                      <a:solidFill>
+                        <a:srgbClr val="C9DED1"/>
+                      </a:solidFill>
+                    </a:lnL>
+                    <a:lnR w="6350">
+                      <a:solidFill>
+                        <a:srgbClr val="C9DED1"/>
+                      </a:solidFill>
+                    </a:lnR>
+                    <a:lnT w="6350">
+                      <a:solidFill>
+                        <a:srgbClr val="C9DED1"/>
+                      </a:solidFill>
+                    </a:lnT>
+                    <a:lnB w="6350">
+                      <a:solidFill>
+                        <a:srgbClr val="C9DED1"/>
+                      </a:solidFill>
+                    </a:lnB>
+                    <a:solidFill>
+                      <a:srgbClr val="F3F7F3"/>
+                    </a:solidFill>
+                  </a:tcPr>
+                </a:tc>
+                <a:tc>
+                  <a:txBody>
+                    <a:bodyPr/>
+                    <a:lstStyle/>
+                    <a:p>
+                      <a:pPr marL="0" indent="0" algn="l">
+                        <a:lnSpc>
+                          <a:spcPct val="100000"/>
+                        </a:lnSpc>
+                        <a:spcBef>
+                          <a:spcPts val="0"/>
+                        </a:spcBef>
+                        <a:spcAft>
+                          <a:spcPts val="0"/>
+                        </a:spcAft>
+                        <a:buNone/>
+                      </a:pPr>
+                      <a:r>
+                        <a:rPr lang="pt-BR" sz="1100" b="0" dirty="0">
+                          <a:solidFill>
+                            <a:srgbClr val="3A3A3A"/>
+                          </a:solidFill>
+                          <a:latin typeface="Montserrat"/>
+                        </a:rPr>
+                        <a:t>não observado</a:t>
+                      </a:r>
+                    </a:p>
+                  </a:txBody>
+                  <a:tcPr marL="64008" marR="64008" marT="36576" marB="36576" anchor="ctr">
+                    <a:lnL w="6350">
+                      <a:solidFill>
+                        <a:srgbClr val="C9DED1"/>
+                      </a:solidFill>
+                    </a:lnL>
+                    <a:lnR w="6350">
+                      <a:solidFill>
+                        <a:srgbClr val="C9DED1"/>
+                      </a:solidFill>
+                    </a:lnR>
+                    <a:lnT w="6350">
+                      <a:solidFill>
+                        <a:srgbClr val="C9DED1"/>
+                      </a:solidFill>
+                    </a:lnT>
+                    <a:lnB w="6350">
+                      <a:solidFill>
+                        <a:srgbClr val="C9DED1"/>
+                      </a:solidFill>
+                    </a:lnB>
+                    <a:solidFill>
+                      <a:srgbClr val="F3F7F3"/>
+                    </a:solidFill>
+                  </a:tcPr>
+                </a:tc>
+              </a:tr>
+              <a:tr h="280162">
+                <a:tc>
+                  <a:txBody>
+                    <a:bodyPr/>
+                    <a:lstStyle/>
+                    <a:p>
+                      <a:pPr marL="0" indent="0" algn="l">
+                        <a:lnSpc>
+                          <a:spcPct val="100000"/>
+                        </a:lnSpc>
+                        <a:spcBef>
+                          <a:spcPts val="0"/>
+                        </a:spcBef>
+                        <a:spcAft>
+                          <a:spcPts val="0"/>
+                        </a:spcAft>
+                        <a:buNone/>
+                      </a:pPr>
+                      <a:r>
+                        <a:rPr lang="pt-BR" sz="1100" b="1" dirty="0">
+                          <a:solidFill>
+                            <a:srgbClr val="3A3A3A"/>
+                          </a:solidFill>
+                          <a:latin typeface="Montserrat"/>
+                        </a:rPr>
+                        <a:t>Municípios por faixa: R$ 10 · 15 · 20 mil</a:t>
+                      </a:r>
+                    </a:p>
+                  </a:txBody>
+                  <a:tcPr marL="64008" marR="64008" marT="36576" marB="36576" anchor="ctr">
+                    <a:lnL w="6350">
+                      <a:solidFill>
+                        <a:srgbClr val="C9DED1"/>
+                      </a:solidFill>
+                    </a:lnL>
+                    <a:lnR w="6350">
+                      <a:solidFill>
+                        <a:srgbClr val="C9DED1"/>
+                      </a:solidFill>
+                    </a:lnR>
+                    <a:lnT w="6350">
+                      <a:solidFill>
+                        <a:srgbClr val="C9DED1"/>
+                      </a:solidFill>
+                    </a:lnT>
+                    <a:lnB w="6350">
+                      <a:solidFill>
+                        <a:srgbClr val="C9DED1"/>
+                      </a:solidFill>
+                    </a:lnB>
+                    <a:solidFill>
+                      <a:srgbClr val="FFFFFF"/>
+                    </a:solidFill>
+                  </a:tcPr>
+                </a:tc>
+                <a:tc>
+                  <a:txBody>
+                    <a:bodyPr/>
+                    <a:lstStyle/>
+                    <a:p>
+                      <a:pPr marL="0" indent="0" algn="l">
+                        <a:lnSpc>
+                          <a:spcPct val="100000"/>
+                        </a:lnSpc>
+                        <a:spcBef>
+                          <a:spcPts val="0"/>
+                        </a:spcBef>
+                        <a:spcAft>
+                          <a:spcPts val="0"/>
+                        </a:spcAft>
+                        <a:buNone/>
+                      </a:pPr>
+                      <a:r>
+                        <a:rPr lang="pt-BR" sz="1100" b="0" dirty="0">
+                          <a:solidFill>
+                            <a:srgbClr val="3A3A3A"/>
+                          </a:solidFill>
+                          <a:latin typeface="Montserrat"/>
+                        </a:rPr>
+                        <a:t>159 · 107 · 102</a:t>
+                      </a:r>
+                    </a:p>
+                  </a:txBody>
+                  <a:tcPr marL="64008" marR="64008" marT="36576" marB="36576" anchor="ctr">
+                    <a:lnL w="6350">
+                      <a:solidFill>
+                        <a:srgbClr val="C9DED1"/>
+                      </a:solidFill>
+                    </a:lnL>
+                    <a:lnR w="6350">
+                      <a:solidFill>
+                        <a:srgbClr val="C9DED1"/>
+                      </a:solidFill>
+                    </a:lnR>
+                    <a:lnT w="6350">
+                      <a:solidFill>
+                        <a:srgbClr val="C9DED1"/>
+                      </a:solidFill>
+                    </a:lnT>
+                    <a:lnB w="6350">
+                      <a:solidFill>
+                        <a:srgbClr val="C9DED1"/>
+                      </a:solidFill>
+                    </a:lnB>
+                    <a:solidFill>
+                      <a:srgbClr val="FFFFFF"/>
+                    </a:solidFill>
+                  </a:tcPr>
+                </a:tc>
+                <a:tc>
+                  <a:txBody>
+                    <a:bodyPr/>
+                    <a:lstStyle/>
+                    <a:p>
+                      <a:pPr marL="0" indent="0" algn="l">
+                        <a:lnSpc>
+                          <a:spcPct val="100000"/>
+                        </a:lnSpc>
+                        <a:spcBef>
+                          <a:spcPts val="0"/>
+                        </a:spcBef>
+                        <a:spcAft>
+                          <a:spcPts val="0"/>
+                        </a:spcAft>
+                        <a:buNone/>
+                      </a:pPr>
+                      <a:r>
+                        <a:rPr lang="pt-BR" sz="1100" b="0" dirty="0">
+                          <a:solidFill>
+                            <a:srgbClr val="3A3A3A"/>
+                          </a:solidFill>
+                          <a:latin typeface="Montserrat"/>
+                        </a:rPr>
+                        <a:t>210 · 115 · 129</a:t>
+                      </a:r>
+                    </a:p>
+                  </a:txBody>
+                  <a:tcPr marL="64008" marR="64008" marT="36576" marB="36576" anchor="ctr">
+                    <a:lnL w="6350">
+                      <a:solidFill>
+                        <a:srgbClr val="C9DED1"/>
+                      </a:solidFill>
+                    </a:lnL>
+                    <a:lnR w="6350">
+                      <a:solidFill>
+                        <a:srgbClr val="C9DED1"/>
+                      </a:solidFill>
+                    </a:lnR>
+                    <a:lnT w="6350">
+                      <a:solidFill>
+                        <a:srgbClr val="C9DED1"/>
+                      </a:solidFill>
+                    </a:lnT>
+                    <a:lnB w="6350">
+                      <a:solidFill>
+                        <a:srgbClr val="C9DED1"/>
+                      </a:solidFill>
+                    </a:lnB>
+                    <a:solidFill>
+                      <a:srgbClr val="FFFFFF"/>
+                    </a:solidFill>
+                  </a:tcPr>
+                </a:tc>
+                <a:tc>
+                  <a:txBody>
+                    <a:bodyPr/>
+                    <a:lstStyle/>
+                    <a:p>
+                      <a:pPr marL="0" indent="0" algn="l">
+                        <a:lnSpc>
+                          <a:spcPct val="100000"/>
+                        </a:lnSpc>
+                        <a:spcBef>
+                          <a:spcPts val="0"/>
+                        </a:spcBef>
+                        <a:spcAft>
+                          <a:spcPts val="0"/>
+                        </a:spcAft>
+                        <a:buNone/>
+                      </a:pPr>
+                      <a:r>
+                        <a:rPr lang="pt-BR" sz="1100" b="0" dirty="0">
                           <a:solidFill>
                             <a:srgbClr val="3A3A3A"/>
                           </a:solidFill>
@@ -24579,8 +25015,8 @@
         </p:nvSpPr>
         <p:spPr>
           <a:xfrm>
-            <a:off x="292608" y="4144264"/>
-            <a:ext cx="11594592" cy="1323848"/>
+            <a:off x="292608" y="4069334"/>
+            <a:ext cx="11594592" cy="1398778"/>
           </a:xfrm>
           <a:prstGeom prst="rect">
             <a:avLst/>
@@ -24665,6 +25101,42 @@
                 <a:latin typeface="Montserrat"/>
               </a:rPr>
               <a:t> alguma confirmação ou homologação; não é taxa de ocupação de vagas.</a:t>
+            </a:r>
+          </a:p>
+          <a:p>
+            <a:pPr marL="201168" indent="-201168" algn="l">
+              <a:lnSpc>
+                <a:spcPct val="104000"/>
+              </a:lnSpc>
+              <a:spcBef>
+                <a:spcPts val="0"/>
+              </a:spcBef>
+              <a:spcAft>
+                <a:spcPts val="900"/>
+              </a:spcAft>
+              <a:buClr>
+                <a:srgbClr val="056429"/>
+              </a:buClr>
+              <a:buFont typeface="Arial"/>
+              <a:buChar char="•"/>
+            </a:pPr>
+            <a:r>
+              <a:rPr lang="pt-BR" sz="1200" b="1" dirty="0">
+                <a:solidFill>
+                  <a:srgbClr val="114719"/>
+                </a:solidFill>
+                <a:latin typeface="Montserrat"/>
+              </a:rPr>
+              <a:t>Candidatos:</a:t>
+            </a:r>
+            <a:r>
+              <a:rPr lang="pt-BR" sz="1200" b="0" dirty="0">
+                <a:solidFill>
+                  <a:srgbClr val="3A3A3A"/>
+                </a:solidFill>
+                <a:latin typeface="Montserrat"/>
+              </a:rPr>
+              <a:t> as linhas com "…" são partes do universo G1 (todos os candidatos nos resultados); a amostra do P1 exige 1ª opção numa célula do quadro, ligação ao CNES e município de origem.</a:t>
             </a:r>
           </a:p>
           <a:p>

</xml_diff>

<commit_message>
Banca 2: slide da H3 com o P1h auditado, linha da H3 na cadeia-resumo e na robustez
- Slide H3: título "no modelo de escolha", figura do P1h sem redesenho (hash
  conferido contra P1h_resumo.json), D_UF com IC e p, K10 com IC que contém
  zero, sensibilidades numa linha, cautela e notas (incentivo limitado;
  coerência com H1; o p unilateral do km não substitui o bilateral do P1a).
- Números H3_* lidos de P1h_magnitudes.csv e P1h_resumo.json; doc 03
  regerado.
- Cadeia-resumo: linha da H3 com força "rejeita zero, pós-resultado" pela
  regra forca_da_linha (Holm + estatuto do bloco).
- Robustez: linha da H3 (BKY nas seis especificações).
- 01, 02, 03 e README sem PENDENTE; testes da H3 refeitos.

Co-Authored-By: Claude Opus 5.5 <noreply@anthropic.com>
Claude-Session: https://claude.ai/code/session_011jPV4G6BtUxSX71P3Fzkr7
</commit_message>
<xml_diff>
--- a/output/apresentacao_banca2/slides_empiricos_banca2.pptx
+++ b/output/apresentacao_banca2/slides_empiricos_banca2.pptx
@@ -9341,7 +9341,7 @@
           <a:p>
             <a:r>
               <a:rPr lang="pt-BR" dirty="0"/>
-              <a:t>Se perguntarem: a comparação usa os mesmos coeficientes do M1. Uma comparação de magnitude com limite não depende de o coeficiente da bolsa ser significativo, ao contrário da disposição a pagar, que é uma razão e explode quando o denominador fica perto de zero. Cautela: PENDENTE: nenhum número da H3 neste slide até a auditoria.</a:t>
+              <a:t>É a hipótese central: incentivo limitado. No modelo de escolha, toda a amplitude da bolsa pesa 0,42 [−0,03; 0,87] na utilidade, e a vaga na mesma UF de origem, fora da região de saúde, pesa 2,40 [2,28; 2,53]. A bolsa pesa pouco perto do custo do lugar. Isso é coerente com a H1 não detectar aumento de preenchimento: a bolsa reordena os candidatos entre as vagas abertas (H2), e o que uma vaga ganha outra do mesmo curso perde; ela não traz mais candidatos, e o logit não vê quem não se inscreveu. Um degrau de R$ 5 mil vale 112 km, também com IC que contém zero. Se perguntarem pelo p de 0,035 do km: é unilateral e descritivo; o teste pré-registrado da bolsa é o bilateral do P1a, com p 0,065, que não rejeita. Não usamos o km como prova de que a bolsa importa. Cautela: Escolha de quem se candidatou, entre vagas abertas: θ é preferência revelada condicional ao modelo, não efeito da geografia; β é o pacote do corte.</a:t>
             </a:r>
           </a:p>
         </p:txBody>
@@ -9459,7 +9459,7 @@
           <a:p>
             <a:r>
               <a:rPr lang="pt-BR" dirty="0"/>
-              <a:t>Ler de cima para baixo, na ordem da cadeia. Cinza: o IC contém o nulo. Verde em N1 é negativo e não passa no Holm. Verde em P6 Y1 é quase mecânico. Verde em P4 é associação: nas horas totais o pré passa e a conclusão aguenta violações de tendência do tamanho das do pré, mas outros outcomes do P4 falham no pré. A força de cada linha sai de uma regra fixa do gerador sobre os valores de output/. A escolha no ciclo 2 aparece no slide da H2. Cautela: Nenhuma pergunta tem hoje evidência causal limpa de mudança no resultado medido.</a:t>
+              <a:t>Ler de cima para baixo, na ordem da cadeia. Cinza: o IC contém o nulo. Verde em N1 é negativo e não passa no Holm. Verde em P6 Y1 é quase mecânico. Verde em P4 é associação: nas horas totais o pré passa e a conclusão aguenta violações de tendência do tamanho das do pré, mas outros outcomes do P4 falham no pré. A força de cada linha sai de uma regra fixa do gerador sobre os valores de output/. A linha da H3 rejeita zero, mas é pós-resultado e compara dois pesos do mesmo modelo de escolha: não é efeito da bolsa nem da geografia. A escolha no ciclo 2 aparece no slide da H2. Cautela: Nenhuma pergunta tem hoje evidência causal limpa de mudança no resultado medido.</a:t>
             </a:r>
           </a:p>
         </p:txBody>
@@ -9518,7 +9518,7 @@
           <a:p>
             <a:r>
               <a:rPr lang="pt-BR" dirty="0"/>
-              <a:t>Duas ressalvas: com um só coeficiente do controle, N1 rejeitaria zero depois do Holm, mas o Wald rejeita essa restrição; e o IC honesto, com o M da regra de bolso, sai largo demais para informar. Ruptura de M̄ igual a 1 quer dizer que a conclusão aguenta violações de tendência do mesmo tamanho das vistas no pré. Cautela: As ressalvas estão na tela: nenhuma especificação foi escolhida depois de ver o resultado.</a:t>
+              <a:t>Duas ressalvas: com um só coeficiente do controle, N1 rejeitaria zero depois do Holm, mas o Wald rejeita essa restrição; e o IC honesto, com o M da regra de bolso, sai largo demais para informar. Ruptura de M̄ igual a 1 quer dizer que a conclusão aguenta violações de tendência do mesmo tamanho das vistas no pré. Na H3, a faixa de 1,18 a 2,37 vai do M2 (distância em log) ao ciclo 3; o q de BKY é o piso da grade do algoritmo, e o P1h é pós-resultado, porque os coeficientes do M1 já eram conhecidos. Cautela: As ressalvas estão na tela: nenhuma especificação foi escolhida depois de ver o resultado.</a:t>
             </a:r>
           </a:p>
         </p:txBody>
@@ -30455,7 +30455,7 @@
                 </a:solidFill>
                 <a:latin typeface="Montserrat"/>
               </a:rPr>
-              <a:t>H3: incentivo limitado — PENDENTE</a:t>
+              <a:t>H3: no modelo de escolha, a UF de origem pesa mais que a bolsa</a:t>
             </a:r>
           </a:p>
         </p:txBody>
@@ -30576,197 +30576,45 @@
           </a:p>
         </p:txBody>
       </p:sp>
+      <p:pic>
+        <p:nvPicPr>
+          <p:cNvPr id="101" name="Figura" descr="H3: pesos na utilidade da escolha da 1ª opção (M1), na mesma escala: bolsa, distância e lugar de origem"/>
+          <p:cNvPicPr>
+            <a:picLocks noChangeAspect="1"/>
+          </p:cNvPicPr>
+          <p:nvPr/>
+        </p:nvPicPr>
+        <p:blipFill>
+          <a:blip r:embed="rId3"/>
+          <a:stretch>
+            <a:fillRect/>
+          </a:stretch>
+        </p:blipFill>
+        <p:spPr>
+          <a:xfrm>
+            <a:off x="292608" y="1002894"/>
+            <a:ext cx="7589520" cy="4266997"/>
+          </a:xfrm>
+          <a:prstGeom prst="rect">
+            <a:avLst/>
+          </a:prstGeom>
+          <a:ln w="6350">
+            <a:solidFill>
+              <a:srgbClr val="DDE7DF"/>
+            </a:solidFill>
+          </a:ln>
+        </p:spPr>
+      </p:pic>
       <p:sp>
         <p:nvSpPr>
-          <p:cNvPr id="101" name="Selo PENDENTE"/>
-          <p:cNvSpPr/>
-          <p:nvPr/>
-        </p:nvSpPr>
-        <p:spPr>
-          <a:xfrm>
-            <a:off x="292608" y="850392"/>
-            <a:ext cx="2834640" cy="566928"/>
-          </a:xfrm>
-          <a:prstGeom prst="roundRect">
-            <a:avLst>
-              <a:gd name="adj" fmla="val 20000"/>
-            </a:avLst>
-          </a:prstGeom>
-          <a:solidFill>
-            <a:srgbClr val="B5470F"/>
-          </a:solidFill>
-          <a:ln>
-            <a:noFill/>
-          </a:ln>
-        </p:spPr>
-        <p:txBody>
-          <a:bodyPr wrap="square" lIns="73152" tIns="45720" rIns="73152" bIns="45720" rtlCol="0" anchor="ctr">
-            <a:noAutofit/>
-          </a:bodyPr>
-          <a:lstStyle/>
-          <a:p>
-            <a:pPr marL="0" indent="0" algn="ctr">
-              <a:lnSpc>
-                <a:spcPct val="100000"/>
-              </a:lnSpc>
-              <a:spcBef>
-                <a:spcPts val="0"/>
-              </a:spcBef>
-              <a:spcAft>
-                <a:spcPts val="0"/>
-              </a:spcAft>
-              <a:buNone/>
-            </a:pPr>
-            <a:r>
-              <a:rPr lang="pt-BR" sz="2600" b="1" spc="200" dirty="0">
-                <a:solidFill>
-                  <a:srgbClr val="FFFFFF"/>
-                </a:solidFill>
-                <a:latin typeface="Montserrat"/>
-              </a:rPr>
-              <a:t>PENDENTE</a:t>
-            </a:r>
-          </a:p>
-        </p:txBody>
-      </p:sp>
-      <p:sp>
-        <p:nvSpPr>
-          <p:cNvPr id="102" name="Selo texto"/>
+          <p:cNvPr id="102" name="Marcadores"/>
           <p:cNvSpPr txBox="1"/>
           <p:nvPr/>
         </p:nvSpPr>
         <p:spPr>
           <a:xfrm>
-            <a:off x="3355848" y="850392"/>
-            <a:ext cx="8531352" cy="566928"/>
-          </a:xfrm>
-          <a:prstGeom prst="rect">
-            <a:avLst/>
-          </a:prstGeom>
-          <a:noFill/>
-          <a:ln>
-            <a:noFill/>
-          </a:ln>
-        </p:spPr>
-        <p:txBody>
-          <a:bodyPr wrap="square" lIns="0" tIns="0" rIns="0" bIns="0" rtlCol="0" anchor="ctr">
-            <a:noAutofit/>
-          </a:bodyPr>
-          <a:lstStyle/>
-          <a:p>
-            <a:pPr marL="0" indent="0" algn="l">
-              <a:lnSpc>
-                <a:spcPct val="100000"/>
-              </a:lnSpc>
-              <a:spcBef>
-                <a:spcPts val="0"/>
-              </a:spcBef>
-              <a:spcAft>
-                <a:spcPts val="0"/>
-              </a:spcAft>
-              <a:buNone/>
-            </a:pPr>
-            <a:r>
-              <a:rPr lang="pt-BR" sz="1400" b="1" dirty="0">
-                <a:solidFill>
-                  <a:srgbClr val="B5470F"/>
-                </a:solidFill>
-                <a:latin typeface="Montserrat"/>
-              </a:rPr>
-              <a:t>Resultado do protocolo 52b em estimação e auditoria. Este slide será trocado.</a:t>
-            </a:r>
-          </a:p>
-        </p:txBody>
-      </p:sp>
-      <p:sp>
-        <p:nvSpPr>
-          <p:cNvPr id="103" name="Espaço da figura"/>
-          <p:cNvSpPr/>
-          <p:nvPr/>
-        </p:nvSpPr>
-        <p:spPr>
-          <a:xfrm>
-            <a:off x="292608" y="1673352"/>
-            <a:ext cx="4937760" cy="3794760"/>
-          </a:xfrm>
-          <a:prstGeom prst="roundRect">
-            <a:avLst>
-              <a:gd name="adj" fmla="val 4000"/>
-            </a:avLst>
-          </a:prstGeom>
-          <a:solidFill>
-            <a:srgbClr val="FDEBD9"/>
-          </a:solidFill>
-          <a:ln w="19050">
-            <a:solidFill>
-              <a:srgbClr val="B5470F"/>
-            </a:solidFill>
-            <a:prstDash val="dash"/>
-          </a:ln>
-        </p:spPr>
-        <p:txBody>
-          <a:bodyPr wrap="square" lIns="73152" tIns="45720" rIns="73152" bIns="45720" rtlCol="0" anchor="ctr">
-            <a:noAutofit/>
-          </a:bodyPr>
-          <a:lstStyle/>
-          <a:p>
-            <a:pPr marL="0" indent="0" algn="ctr">
-              <a:lnSpc>
-                <a:spcPct val="100000"/>
-              </a:lnSpc>
-              <a:spcBef>
-                <a:spcPts val="0"/>
-              </a:spcBef>
-              <a:spcAft>
-                <a:spcPts val="0"/>
-              </a:spcAft>
-              <a:buNone/>
-            </a:pPr>
-            <a:r>
-              <a:rPr lang="pt-BR" sz="1600" b="1" dirty="0">
-                <a:solidFill>
-                  <a:srgbClr val="B5470F"/>
-                </a:solidFill>
-                <a:latin typeface="Montserrat"/>
-              </a:rPr>
-              <a:t>figura da H3</a:t>
-            </a:r>
-          </a:p>
-          <a:p>
-            <a:pPr marL="0" indent="0" algn="ctr">
-              <a:lnSpc>
-                <a:spcPct val="100000"/>
-              </a:lnSpc>
-              <a:spcBef>
-                <a:spcPts val="0"/>
-              </a:spcBef>
-              <a:spcAft>
-                <a:spcPts val="0"/>
-              </a:spcAft>
-              <a:buNone/>
-            </a:pPr>
-            <a:r>
-              <a:rPr lang="pt-BR" sz="1100" b="0" dirty="0">
-                <a:solidFill>
-                  <a:srgbClr val="B5470F"/>
-                </a:solidFill>
-                <a:latin typeface="Montserrat"/>
-              </a:rPr>
-              <a:t>coeficientes do M1 na mesma escala de utilidade</a:t>
-            </a:r>
-          </a:p>
-        </p:txBody>
-      </p:sp>
-      <p:sp>
-        <p:nvSpPr>
-          <p:cNvPr id="104" name="Marcadores"/>
-          <p:cNvSpPr txBox="1"/>
-          <p:nvPr/>
-        </p:nvSpPr>
-        <p:spPr>
-          <a:xfrm>
-            <a:off x="5550408" y="1764792"/>
-            <a:ext cx="6336792" cy="3703320"/>
+            <a:off x="8156448" y="1048614"/>
+            <a:ext cx="3730752" cy="4419498"/>
           </a:xfrm>
           <a:prstGeom prst="rect">
             <a:avLst/>
@@ -30799,22 +30647,22 @@
               <a:buChar char="•"/>
             </a:pPr>
             <a:r>
-              <a:rPr lang="pt-BR" sz="1300" b="1" dirty="0">
+              <a:rPr lang="pt-BR" sz="1250" b="1" dirty="0">
                 <a:solidFill>
                   <a:srgbClr val="114719"/>
                 </a:solidFill>
                 <a:latin typeface="Montserrat"/>
               </a:rPr>
-              <a:t>Teste congelado</a:t>
-            </a:r>
-            <a:r>
-              <a:rPr lang="pt-BR" sz="1300" b="0" dirty="0">
+              <a:t>Primária (P1h-1):</a:t>
+            </a:r>
+            <a:r>
+              <a:rPr lang="pt-BR" sz="1250" b="0" dirty="0">
                 <a:solidFill>
                   <a:srgbClr val="3A3A3A"/>
                 </a:solidFill>
                 <a:latin typeface="Montserrat"/>
               </a:rPr>
-              <a:t> no protocolo 52b em 26/10/2026, antes de calcular: o efeito de toda a amplitude da bolsa (R$ 10 mil → R$ 20 mil) é menor que o de a vaga ficar na UF de origem?</a:t>
+              <a:t> D_UF = θ_UF − 10·β = 1,98 [1,56; 2,40], p unilateral &lt; 0,001 (Holm, família de um teste): toda a amplitude da bolsa (R$ 10 → 20 mil) pesa menos que a vaga estar na UF de origem.</a:t>
             </a:r>
           </a:p>
           <a:p>
@@ -30835,22 +30683,22 @@
               <a:buChar char="•"/>
             </a:pPr>
             <a:r>
-              <a:rPr lang="pt-BR" sz="1300" b="1" dirty="0">
+              <a:rPr lang="pt-BR" sz="1250" b="1" dirty="0">
                 <a:solidFill>
                   <a:srgbClr val="114719"/>
                 </a:solidFill>
                 <a:latin typeface="Montserrat"/>
               </a:rPr>
-              <a:t>Também:</a:t>
-            </a:r>
-            <a:r>
-              <a:rPr lang="pt-BR" sz="1300" b="0" dirty="0">
+              <a:t>Lugar:</a:t>
+            </a:r>
+            <a:r>
+              <a:rPr lang="pt-BR" sz="1250" b="0" dirty="0">
                 <a:solidFill>
                   <a:srgbClr val="3A3A3A"/>
                 </a:solidFill>
                 <a:latin typeface="Montserrat"/>
               </a:rPr>
-              <a:t> a amplitude da bolsa expressa em km equivalentes de distância, com IC.</a:t>
+              <a:t> θ_UF é mesma UF, outra região de saúde, contra uma vaga em outra UF à mesma distância.</a:t>
             </a:r>
           </a:p>
           <a:p>
@@ -30871,29 +30719,65 @@
               <a:buChar char="•"/>
             </a:pPr>
             <a:r>
-              <a:rPr lang="pt-BR" sz="1300" b="1" dirty="0">
+              <a:rPr lang="pt-BR" sz="1250" b="1" dirty="0">
                 <a:solidFill>
                   <a:srgbClr val="114719"/>
                 </a:solidFill>
                 <a:latin typeface="Montserrat"/>
               </a:rPr>
-              <a:t>Estado:</a:t>
-            </a:r>
-            <a:r>
-              <a:rPr lang="pt-BR" sz="1300" b="0" dirty="0">
+              <a:t>Em km (descritivo):</a:t>
+            </a:r>
+            <a:r>
+              <a:rPr lang="pt-BR" sz="1250" b="0" dirty="0">
                 <a:solidFill>
                   <a:srgbClr val="3A3A3A"/>
                 </a:solidFill>
                 <a:latin typeface="Montserrat"/>
               </a:rPr>
-              <a:t> o script 25c (doc 57i) está sendo rodado por outra sessão e passa por auditoria independente antes de entrar aqui.</a:t>
+              <a:t> toda a amplitude da bolsa vale 224 km a menos de distância [−18; 466]; o IC contém zero, como o de β.</a:t>
+            </a:r>
+          </a:p>
+          <a:p>
+            <a:pPr marL="201168" indent="-201168" algn="l">
+              <a:lnSpc>
+                <a:spcPct val="104000"/>
+              </a:lnSpc>
+              <a:spcBef>
+                <a:spcPts val="0"/>
+              </a:spcBef>
+              <a:spcAft>
+                <a:spcPts val="900"/>
+              </a:spcAft>
+              <a:buClr>
+                <a:srgbClr val="056429"/>
+              </a:buClr>
+              <a:buFont typeface="Arial"/>
+              <a:buChar char="•"/>
+            </a:pPr>
+            <a:r>
+              <a:rPr lang="pt-BR" sz="1250" b="1" dirty="0">
+                <a:solidFill>
+                  <a:srgbClr val="114719"/>
+                </a:solidFill>
+                <a:latin typeface="Montserrat"/>
+              </a:rPr>
+              <a:t>Sensibilidades:</a:t>
+            </a:r>
+            <a:r>
+              <a:rPr lang="pt-BR" sz="1250" b="0" dirty="0">
+                <a:solidFill>
+                  <a:srgbClr val="3A3A3A"/>
+                </a:solidFill>
+                <a:latin typeface="Montserrat"/>
+              </a:rPr>
+              <a:t> D_UF positivo em todas: M2 1,18 · M4 1,73 · M5 por ciclo 2,34 · 1,31 · 2,37 · M7 2,07.</a:t>
             </a:r>
           </a:p>
         </p:txBody>
       </p:sp>
       <p:sp>
         <p:nvSpPr>
-          <p:cNvPr id="105" name="Cautela"/>
+          <p:cNvPr id="103" name="Cautela"/>
           <p:cNvSpPr/>
           <p:nvPr/>
         </p:nvSpPr>
@@ -30908,7 +30792,7 @@
             </a:avLst>
           </a:prstGeom>
           <a:solidFill>
-            <a:srgbClr val="FDEBD9"/>
+            <a:srgbClr val="E7F1EA"/>
           </a:solidFill>
           <a:ln>
             <a:noFill/>
@@ -30935,18 +30819,18 @@
             <a:r>
               <a:rPr lang="pt-BR" sz="1250" b="1" dirty="0">
                 <a:solidFill>
-                  <a:srgbClr val="B5470F"/>
+                  <a:srgbClr val="114719"/>
                 </a:solidFill>
                 <a:latin typeface="Montserrat"/>
               </a:rPr>
-              <a:t>PENDENTE: nenhum número da H3 neste slide até a auditoria.</a:t>
+              <a:t>Escolha de quem se candidatou, entre vagas abertas: θ é preferência revelada condicional ao modelo, não efeito da geografia; β é o pacote do corte.</a:t>
             </a:r>
           </a:p>
         </p:txBody>
       </p:sp>
       <p:sp>
         <p:nvSpPr>
-          <p:cNvPr id="106" name="Fontes"/>
+          <p:cNvPr id="104" name="Fontes"/>
           <p:cNvSpPr txBox="1"/>
           <p:nvPr/>
         </p:nvSpPr>
@@ -30997,7 +30881,7 @@
                 </a:solidFill>
                 <a:latin typeface="Montserrat"/>
               </a:rPr>
-              <a:t>docs/06_execucao/52b_protocolo_P1h_magnitudes.md.</a:t>
+              <a:t>output/rdd_bolsa/P1h_magnitudes.csv e P1h_resumo.json (doc 57i; protocolo 52b, pós-resultado); figura output/rdd_bolsa/P1h_figuras/P1h_magnitudes.png, gravada pelo script 25c, com os rótulos corrigidos pela auditoria 31 (achados A1 e A2).</a:t>
             </a:r>
           </a:p>
         </p:txBody>
@@ -31615,7 +31499,7 @@
         <p:spPr>
           <a:xfrm>
             <a:off x="292608" y="804672"/>
-            <a:ext cx="7942537" cy="5239512"/>
+            <a:ext cx="7069635" cy="5239512"/>
           </a:xfrm>
           <a:prstGeom prst="rect">
             <a:avLst/>
@@ -31635,8 +31519,8 @@
         </p:nvSpPr>
         <p:spPr>
           <a:xfrm>
-            <a:off x="8509465" y="804672"/>
-            <a:ext cx="3377735" cy="5239512"/>
+            <a:off x="7636563" y="804672"/>
+            <a:ext cx="4250637" cy="5239512"/>
           </a:xfrm>
           <a:prstGeom prst="roundRect">
             <a:avLst>
@@ -31733,7 +31617,7 @@
                 </a:solidFill>
                 <a:latin typeface="Montserrat"/>
               </a:rPr>
-              <a:t>output/rdd_bolsa/S57_resumo.json (doc 57, §2 e §4); figura por scripts/apresentacao/gerar_figuras_banca2.py.</a:t>
+              <a:t>output/rdd_bolsa/S57_resumo.json (doc 57, §2 e §4); output/rdd_bolsa/P1h_magnitudes.csv (doc 57i); figura por scripts/apresentacao/gerar_figuras_banca2.py.</a:t>
             </a:r>
           </a:p>
         </p:txBody>
@@ -31927,19 +31811,19 @@
         </p:nvGraphicFramePr>
         <p:xfrm>
           <a:off x="292608" y="804672"/>
-          <a:ext cx="11594592" cy="4583430"/>
+          <a:ext cx="11594592" cy="4445254"/>
         </p:xfrm>
         <a:graphic>
           <a:graphicData uri="http://schemas.openxmlformats.org/drawingml/2006/table">
             <a:tbl>
               <a:tblPr firstRow="1" bandRow="1"/>
               <a:tblGrid>
-                <a:gridCol w="988568"/>
-                <a:gridCol w="3511196"/>
-                <a:gridCol w="3210760"/>
-                <a:gridCol w="3884068"/>
+                <a:gridCol w="894080"/>
+                <a:gridCol w="3563985"/>
+                <a:gridCol w="3186536"/>
+                <a:gridCol w="3949990"/>
               </a:tblGrid>
-              <a:tr h="303403">
+              <a:tr h="280162">
                 <a:tc>
                   <a:txBody>
                     <a:bodyPr/>
@@ -31958,7 +31842,7 @@
                         <a:buNone/>
                       </a:pPr>
                       <a:r>
-                        <a:rPr lang="pt-BR" sz="1250" b="1" dirty="0">
+                        <a:rPr lang="pt-BR" sz="1100" b="1" dirty="0">
                           <a:solidFill>
                             <a:srgbClr val="FFFFFF"/>
                           </a:solidFill>
@@ -32012,7 +31896,7 @@
                         <a:buNone/>
                       </a:pPr>
                       <a:r>
-                        <a:rPr lang="pt-BR" sz="1250" b="1" dirty="0">
+                        <a:rPr lang="pt-BR" sz="1100" b="1" dirty="0">
                           <a:solidFill>
                             <a:srgbClr val="FFFFFF"/>
                           </a:solidFill>
@@ -32066,7 +31950,7 @@
                         <a:buNone/>
                       </a:pPr>
                       <a:r>
-                        <a:rPr lang="pt-BR" sz="1250" b="1" dirty="0">
+                        <a:rPr lang="pt-BR" sz="1100" b="1" dirty="0">
                           <a:solidFill>
                             <a:srgbClr val="FFFFFF"/>
                           </a:solidFill>
@@ -32120,7 +32004,7 @@
                         <a:buNone/>
                       </a:pPr>
                       <a:r>
-                        <a:rPr lang="pt-BR" sz="1250" b="1" dirty="0">
+                        <a:rPr lang="pt-BR" sz="1100" b="1" dirty="0">
                           <a:solidFill>
                             <a:srgbClr val="FFFFFF"/>
                           </a:solidFill>
@@ -32157,7 +32041,7 @@
                   </a:tcPr>
                 </a:tc>
               </a:tr>
-              <a:tr h="497078">
+              <a:tr h="280162">
                 <a:tc>
                   <a:txBody>
                     <a:bodyPr/>
@@ -32176,7 +32060,7 @@
                         <a:buNone/>
                       </a:pPr>
                       <a:r>
-                        <a:rPr lang="pt-BR" sz="1250" b="1" dirty="0">
+                        <a:rPr lang="pt-BR" sz="1100" b="1" dirty="0">
                           <a:solidFill>
                             <a:srgbClr val="3A3A3A"/>
                           </a:solidFill>
@@ -32230,7 +32114,7 @@
                         <a:buNone/>
                       </a:pPr>
                       <a:r>
-                        <a:rPr lang="pt-BR" sz="1250" b="0" dirty="0">
+                        <a:rPr lang="pt-BR" sz="1100" b="0" dirty="0">
                           <a:solidFill>
                             <a:srgbClr val="3A3A3A"/>
                           </a:solidFill>
@@ -32284,7 +32168,7 @@
                         <a:buNone/>
                       </a:pPr>
                       <a:r>
-                        <a:rPr lang="pt-BR" sz="1250" b="0" dirty="0">
+                        <a:rPr lang="pt-BR" sz="1100" b="0" dirty="0">
                           <a:solidFill>
                             <a:srgbClr val="3A3A3A"/>
                           </a:solidFill>
@@ -32338,7 +32222,7 @@
                         <a:buNone/>
                       </a:pPr>
                       <a:r>
-                        <a:rPr lang="pt-BR" sz="1250" b="0" dirty="0">
+                        <a:rPr lang="pt-BR" sz="1100" b="0" dirty="0">
                           <a:solidFill>
                             <a:srgbClr val="3A3A3A"/>
                           </a:solidFill>
@@ -32375,7 +32259,7 @@
                   </a:tcPr>
                 </a:tc>
               </a:tr>
-              <a:tr h="497078">
+              <a:tr h="450596">
                 <a:tc>
                   <a:txBody>
                     <a:bodyPr/>
@@ -32394,7 +32278,7 @@
                         <a:buNone/>
                       </a:pPr>
                       <a:r>
-                        <a:rPr lang="pt-BR" sz="1250" b="1" dirty="0">
+                        <a:rPr lang="pt-BR" sz="1100" b="1" dirty="0">
                           <a:solidFill>
                             <a:srgbClr val="3A3A3A"/>
                           </a:solidFill>
@@ -32448,7 +32332,7 @@
                         <a:buNone/>
                       </a:pPr>
                       <a:r>
-                        <a:rPr lang="pt-BR" sz="1250" b="0" dirty="0">
+                        <a:rPr lang="pt-BR" sz="1100" b="0" dirty="0">
                           <a:solidFill>
                             <a:srgbClr val="3A3A3A"/>
                           </a:solidFill>
@@ -32502,7 +32386,7 @@
                         <a:buNone/>
                       </a:pPr>
                       <a:r>
-                        <a:rPr lang="pt-BR" sz="1250" b="0" dirty="0">
+                        <a:rPr lang="pt-BR" sz="1100" b="0" dirty="0">
                           <a:solidFill>
                             <a:srgbClr val="3A3A3A"/>
                           </a:solidFill>
@@ -32556,7 +32440,7 @@
                         <a:buNone/>
                       </a:pPr>
                       <a:r>
-                        <a:rPr lang="pt-BR" sz="1250" b="0" dirty="0">
+                        <a:rPr lang="pt-BR" sz="1100" b="0" dirty="0">
                           <a:solidFill>
                             <a:srgbClr val="3A3A3A"/>
                           </a:solidFill>
@@ -32593,7 +32477,7 @@
                   </a:tcPr>
                 </a:tc>
               </a:tr>
-              <a:tr h="497078">
+              <a:tr h="450596">
                 <a:tc>
                   <a:txBody>
                     <a:bodyPr/>
@@ -32612,7 +32496,7 @@
                         <a:buNone/>
                       </a:pPr>
                       <a:r>
-                        <a:rPr lang="pt-BR" sz="1250" b="1" dirty="0">
+                        <a:rPr lang="pt-BR" sz="1100" b="1" dirty="0">
                           <a:solidFill>
                             <a:srgbClr val="3A3A3A"/>
                           </a:solidFill>
@@ -32666,7 +32550,7 @@
                         <a:buNone/>
                       </a:pPr>
                       <a:r>
-                        <a:rPr lang="pt-BR" sz="1250" b="0" dirty="0">
+                        <a:rPr lang="pt-BR" sz="1100" b="0" dirty="0">
                           <a:solidFill>
                             <a:srgbClr val="3A3A3A"/>
                           </a:solidFill>
@@ -32720,7 +32604,7 @@
                         <a:buNone/>
                       </a:pPr>
                       <a:r>
-                        <a:rPr lang="pt-BR" sz="1250" b="0" dirty="0">
+                        <a:rPr lang="pt-BR" sz="1100" b="0" dirty="0">
                           <a:solidFill>
                             <a:srgbClr val="3A3A3A"/>
                           </a:solidFill>
@@ -32774,7 +32658,7 @@
                         <a:buNone/>
                       </a:pPr>
                       <a:r>
-                        <a:rPr lang="pt-BR" sz="1250" b="1" dirty="0">
+                        <a:rPr lang="pt-BR" sz="1100" b="1" dirty="0">
                           <a:solidFill>
                             <a:srgbClr val="114719"/>
                           </a:solidFill>
@@ -32783,7 +32667,7 @@
                         <a:t>ressalva:</a:t>
                       </a:r>
                       <a:r>
-                        <a:rPr lang="pt-BR" sz="1250" b="0" dirty="0">
+                        <a:rPr lang="pt-BR" sz="1100" b="0" dirty="0">
                           <a:solidFill>
                             <a:srgbClr val="3A3A3A"/>
                           </a:solidFill>
@@ -32820,7 +32704,7 @@
                   </a:tcPr>
                 </a:tc>
               </a:tr>
-              <a:tr h="303403">
+              <a:tr h="280162">
                 <a:tc>
                   <a:txBody>
                     <a:bodyPr/>
@@ -32839,7 +32723,7 @@
                         <a:buNone/>
                       </a:pPr>
                       <a:r>
-                        <a:rPr lang="pt-BR" sz="1250" b="1" dirty="0">
+                        <a:rPr lang="pt-BR" sz="1100" b="1" dirty="0">
                           <a:solidFill>
                             <a:srgbClr val="3A3A3A"/>
                           </a:solidFill>
@@ -32893,7 +32777,7 @@
                         <a:buNone/>
                       </a:pPr>
                       <a:r>
-                        <a:rPr lang="pt-BR" sz="1250" b="0" dirty="0">
+                        <a:rPr lang="pt-BR" sz="1100" b="0" dirty="0">
                           <a:solidFill>
                             <a:srgbClr val="3A3A3A"/>
                           </a:solidFill>
@@ -32947,7 +32831,7 @@
                         <a:buNone/>
                       </a:pPr>
                       <a:r>
-                        <a:rPr lang="pt-BR" sz="1250" b="0" dirty="0">
+                        <a:rPr lang="pt-BR" sz="1100" b="0" dirty="0">
                           <a:solidFill>
                             <a:srgbClr val="3A3A3A"/>
                           </a:solidFill>
@@ -33001,7 +32885,7 @@
                         <a:buNone/>
                       </a:pPr>
                       <a:r>
-                        <a:rPr lang="pt-BR" sz="1250" b="1" dirty="0">
+                        <a:rPr lang="pt-BR" sz="1100" b="1" dirty="0">
                           <a:solidFill>
                             <a:srgbClr val="114719"/>
                           </a:solidFill>
@@ -33010,7 +32894,7 @@
                         <a:t>ressalva:</a:t>
                       </a:r>
                       <a:r>
-                        <a:rPr lang="pt-BR" sz="1250" b="0" dirty="0">
+                        <a:rPr lang="pt-BR" sz="1100" b="0" dirty="0">
                           <a:solidFill>
                             <a:srgbClr val="3A3A3A"/>
                           </a:solidFill>
@@ -33047,7 +32931,7 @@
                   </a:tcPr>
                 </a:tc>
               </a:tr>
-              <a:tr h="497078">
+              <a:tr h="450596">
                 <a:tc>
                   <a:txBody>
                     <a:bodyPr/>
@@ -33066,7 +32950,7 @@
                         <a:buNone/>
                       </a:pPr>
                       <a:r>
-                        <a:rPr lang="pt-BR" sz="1250" b="1" dirty="0">
+                        <a:rPr lang="pt-BR" sz="1100" b="1" dirty="0">
                           <a:solidFill>
                             <a:srgbClr val="3A3A3A"/>
                           </a:solidFill>
@@ -33120,7 +33004,7 @@
                         <a:buNone/>
                       </a:pPr>
                       <a:r>
-                        <a:rPr lang="pt-BR" sz="1250" b="0" dirty="0">
+                        <a:rPr lang="pt-BR" sz="1100" b="0" dirty="0">
                           <a:solidFill>
                             <a:srgbClr val="3A3A3A"/>
                           </a:solidFill>
@@ -33174,7 +33058,7 @@
                         <a:buNone/>
                       </a:pPr>
                       <a:r>
-                        <a:rPr lang="pt-BR" sz="1250" b="0" dirty="0">
+                        <a:rPr lang="pt-BR" sz="1100" b="0" dirty="0">
                           <a:solidFill>
                             <a:srgbClr val="3A3A3A"/>
                           </a:solidFill>
@@ -33228,7 +33112,7 @@
                         <a:buNone/>
                       </a:pPr>
                       <a:r>
-                        <a:rPr lang="pt-BR" sz="1250" b="0" dirty="0">
+                        <a:rPr lang="pt-BR" sz="1100" b="0" dirty="0">
                           <a:solidFill>
                             <a:srgbClr val="3A3A3A"/>
                           </a:solidFill>
@@ -33265,7 +33149,7 @@
                   </a:tcPr>
                 </a:tc>
               </a:tr>
-              <a:tr h="497078">
+              <a:tr h="450596">
                 <a:tc>
                   <a:txBody>
                     <a:bodyPr/>
@@ -33284,7 +33168,7 @@
                         <a:buNone/>
                       </a:pPr>
                       <a:r>
-                        <a:rPr lang="pt-BR" sz="1250" b="1" dirty="0">
+                        <a:rPr lang="pt-BR" sz="1100" b="1" dirty="0">
                           <a:solidFill>
                             <a:srgbClr val="3A3A3A"/>
                           </a:solidFill>
@@ -33338,7 +33222,7 @@
                         <a:buNone/>
                       </a:pPr>
                       <a:r>
-                        <a:rPr lang="pt-BR" sz="1250" b="0" dirty="0">
+                        <a:rPr lang="pt-BR" sz="1100" b="0" dirty="0">
                           <a:solidFill>
                             <a:srgbClr val="3A3A3A"/>
                           </a:solidFill>
@@ -33392,7 +33276,7 @@
                         <a:buNone/>
                       </a:pPr>
                       <a:r>
-                        <a:rPr lang="pt-BR" sz="1250" b="0" dirty="0">
+                        <a:rPr lang="pt-BR" sz="1100" b="0" dirty="0">
                           <a:solidFill>
                             <a:srgbClr val="3A3A3A"/>
                           </a:solidFill>
@@ -33446,7 +33330,7 @@
                         <a:buNone/>
                       </a:pPr>
                       <a:r>
-                        <a:rPr lang="pt-BR" sz="1250" b="0" dirty="0">
+                        <a:rPr lang="pt-BR" sz="1100" b="0" dirty="0">
                           <a:solidFill>
                             <a:srgbClr val="3A3A3A"/>
                           </a:solidFill>
@@ -33483,7 +33367,7 @@
                   </a:tcPr>
                 </a:tc>
               </a:tr>
-              <a:tr h="497078">
+              <a:tr h="450596">
                 <a:tc>
                   <a:txBody>
                     <a:bodyPr/>
@@ -33502,13 +33386,13 @@
                         <a:buNone/>
                       </a:pPr>
                       <a:r>
-                        <a:rPr lang="pt-BR" sz="1250" b="1" dirty="0">
+                        <a:rPr lang="pt-BR" sz="1100" b="1" dirty="0">
                           <a:solidFill>
                             <a:srgbClr val="3A3A3A"/>
                           </a:solidFill>
                           <a:latin typeface="Montserrat"/>
                         </a:rPr>
-                        <a:t>H4</a:t>
+                        <a:t>H3</a:t>
                       </a:r>
                     </a:p>
                   </a:txBody>
@@ -33556,13 +33440,13 @@
                         <a:buNone/>
                       </a:pPr>
                       <a:r>
-                        <a:rPr lang="pt-BR" sz="1250" b="0" dirty="0">
+                        <a:rPr lang="pt-BR" sz="1100" b="0" dirty="0">
                           <a:solidFill>
                             <a:srgbClr val="3A3A3A"/>
                           </a:solidFill>
                           <a:latin typeface="Montserrat"/>
                         </a:rPr>
-                        <a:t>Rambachan–Roth (Δ^RM, média do pós)</a:t>
+                        <a:t>D_UF em M2, M4, M5 por ciclo e M7 (BKY entre as seis)</a:t>
                       </a:r>
                     </a:p>
                   </a:txBody>
@@ -33610,13 +33494,13 @@
                         <a:buNone/>
                       </a:pPr>
                       <a:r>
-                        <a:rPr lang="pt-BR" sz="1250" b="0" dirty="0">
+                        <a:rPr lang="pt-BR" sz="1100" b="0" dirty="0">
                           <a:solidFill>
                             <a:srgbClr val="3A3A3A"/>
                           </a:solidFill>
                           <a:latin typeface="Montserrat"/>
                         </a:rPr>
-                        <a:t>ruptura de M̄: 1,30 (totais), 1,90 (posto), 0,78 (fora)</a:t>
+                        <a:t>de 1,18 a 2,37</a:t>
                       </a:r>
                     </a:p>
                   </a:txBody>
@@ -33664,13 +33548,13 @@
                         <a:buNone/>
                       </a:pPr>
                       <a:r>
-                        <a:rPr lang="pt-BR" sz="1250" b="0" dirty="0">
+                        <a:rPr lang="pt-BR" sz="1100" b="0" dirty="0">
                           <a:solidFill>
                             <a:srgbClr val="3A3A3A"/>
                           </a:solidFill>
                           <a:latin typeface="Montserrat"/>
                         </a:rPr>
-                        <a:t>totais e posto aguentam violações do tamanho das do pré</a:t>
+                        <a:t>positivo em todas, com q de BKY &lt; 0,05; pós-resultado</a:t>
                       </a:r>
                     </a:p>
                   </a:txBody>
@@ -33701,7 +33585,7 @@
                   </a:tcPr>
                 </a:tc>
               </a:tr>
-              <a:tr h="497078">
+              <a:tr h="450596">
                 <a:tc>
                   <a:txBody>
                     <a:bodyPr/>
@@ -33720,7 +33604,7 @@
                         <a:buNone/>
                       </a:pPr>
                       <a:r>
-                        <a:rPr lang="pt-BR" sz="1250" b="1" dirty="0">
+                        <a:rPr lang="pt-BR" sz="1100" b="1" dirty="0">
                           <a:solidFill>
                             <a:srgbClr val="3A3A3A"/>
                           </a:solidFill>
@@ -33774,13 +33658,13 @@
                         <a:buNone/>
                       </a:pPr>
                       <a:r>
-                        <a:rPr lang="pt-BR" sz="1250" b="0" dirty="0">
+                        <a:rPr lang="pt-BR" sz="1100" b="0" dirty="0">
                           <a:solidFill>
                             <a:srgbClr val="3A3A3A"/>
                           </a:solidFill>
                           <a:latin typeface="Montserrat"/>
                         </a:rPr>
-                        <a:t>comparação na nota de corte (P4-CA)</a:t>
+                        <a:t>Rambachan–Roth (Δ^RM, média do pós)</a:t>
                       </a:r>
                     </a:p>
                   </a:txBody>
@@ -33828,13 +33712,13 @@
                         <a:buNone/>
                       </a:pPr>
                       <a:r>
-                        <a:rPr lang="pt-BR" sz="1250" b="0" dirty="0">
+                        <a:rPr lang="pt-BR" sz="1100" b="0" dirty="0">
                           <a:solidFill>
                             <a:srgbClr val="3A3A3A"/>
                           </a:solidFill>
                           <a:latin typeface="Montserrat"/>
                         </a:rPr>
-                        <a:t>totais +7,91 [−0,63; +16,45]; pré p 0,837</a:t>
+                        <a:t>ruptura de M̄: 1,30 (totais), 1,90 (posto), 0,78 (fora)</a:t>
                       </a:r>
                     </a:p>
                   </a:txBody>
@@ -33882,13 +33766,13 @@
                         <a:buNone/>
                       </a:pPr>
                       <a:r>
-                        <a:rPr lang="pt-BR" sz="1250" b="0" dirty="0">
+                        <a:rPr lang="pt-BR" sz="1100" b="0" dirty="0">
                           <a:solidFill>
                             <a:srgbClr val="3A3A3A"/>
                           </a:solidFill>
                           <a:latin typeface="Montserrat"/>
                         </a:rPr>
-                        <a:t>mesma direção; o IC contém zero</a:t>
+                        <a:t>totais e posto aguentam violações do tamanho das do pré</a:t>
                       </a:r>
                     </a:p>
                   </a:txBody>
@@ -33919,7 +33803,7 @@
                   </a:tcPr>
                 </a:tc>
               </a:tr>
-              <a:tr h="497078">
+              <a:tr h="450596">
                 <a:tc>
                   <a:txBody>
                     <a:bodyPr/>
@@ -33938,13 +33822,13 @@
                         <a:buNone/>
                       </a:pPr>
                       <a:r>
-                        <a:rPr lang="pt-BR" sz="1250" b="1" dirty="0">
+                        <a:rPr lang="pt-BR" sz="1100" b="1" dirty="0">
                           <a:solidFill>
                             <a:srgbClr val="3A3A3A"/>
                           </a:solidFill>
                           <a:latin typeface="Montserrat"/>
                         </a:rPr>
-                        <a:t>todas</a:t>
+                        <a:t>H4</a:t>
                       </a:r>
                     </a:p>
                   </a:txBody>
@@ -33992,13 +33876,13 @@
                         <a:buNone/>
                       </a:pPr>
                       <a:r>
-                        <a:rPr lang="pt-BR" sz="1250" b="0" dirty="0">
+                        <a:rPr lang="pt-BR" sz="1100" b="0" dirty="0">
                           <a:solidFill>
                             <a:srgbClr val="3A3A3A"/>
                           </a:solidFill>
                           <a:latin typeface="Montserrat"/>
                         </a:rPr>
-                        <a:t>Holm nas primárias; BKY nas secundárias</a:t>
+                        <a:t>comparação na nota de corte (P4-CA)</a:t>
                       </a:r>
                     </a:p>
                   </a:txBody>
@@ -34046,13 +33930,13 @@
                         <a:buNone/>
                       </a:pPr>
                       <a:r>
-                        <a:rPr lang="pt-BR" sz="1250" b="0" dirty="0">
+                        <a:rPr lang="pt-BR" sz="1100" b="0" dirty="0">
                           <a:solidFill>
                             <a:srgbClr val="3A3A3A"/>
                           </a:solidFill>
                           <a:latin typeface="Montserrat"/>
                         </a:rPr>
-                        <a:t>nenhuma primária rejeita zero, salvo o Y1 do P6</a:t>
+                        <a:t>totais +7,91 [−0,63; +16,45]; pré p 0,837</a:t>
                       </a:r>
                     </a:p>
                   </a:txBody>
@@ -34100,7 +33984,225 @@
                         <a:buNone/>
                       </a:pPr>
                       <a:r>
-                        <a:rPr lang="pt-BR" sz="1250" b="0" dirty="0">
+                        <a:rPr lang="pt-BR" sz="1100" b="0" dirty="0">
+                          <a:solidFill>
+                            <a:srgbClr val="3A3A3A"/>
+                          </a:solidFill>
+                          <a:latin typeface="Montserrat"/>
+                        </a:rPr>
+                        <a:t>mesma direção; o IC contém zero</a:t>
+                      </a:r>
+                    </a:p>
+                  </a:txBody>
+                  <a:tcPr marL="64008" marR="64008" marT="36576" marB="36576" anchor="ctr">
+                    <a:lnL w="6350">
+                      <a:solidFill>
+                        <a:srgbClr val="C9DED1"/>
+                      </a:solidFill>
+                    </a:lnL>
+                    <a:lnR w="6350">
+                      <a:solidFill>
+                        <a:srgbClr val="C9DED1"/>
+                      </a:solidFill>
+                    </a:lnR>
+                    <a:lnT w="6350">
+                      <a:solidFill>
+                        <a:srgbClr val="C9DED1"/>
+                      </a:solidFill>
+                    </a:lnT>
+                    <a:lnB w="6350">
+                      <a:solidFill>
+                        <a:srgbClr val="C9DED1"/>
+                      </a:solidFill>
+                    </a:lnB>
+                    <a:solidFill>
+                      <a:srgbClr val="F3F7F3"/>
+                    </a:solidFill>
+                  </a:tcPr>
+                </a:tc>
+              </a:tr>
+              <a:tr h="450596">
+                <a:tc>
+                  <a:txBody>
+                    <a:bodyPr/>
+                    <a:lstStyle/>
+                    <a:p>
+                      <a:pPr marL="0" indent="0" algn="l">
+                        <a:lnSpc>
+                          <a:spcPct val="100000"/>
+                        </a:lnSpc>
+                        <a:spcBef>
+                          <a:spcPts val="0"/>
+                        </a:spcBef>
+                        <a:spcAft>
+                          <a:spcPts val="0"/>
+                        </a:spcAft>
+                        <a:buNone/>
+                      </a:pPr>
+                      <a:r>
+                        <a:rPr lang="pt-BR" sz="1100" b="1" dirty="0">
+                          <a:solidFill>
+                            <a:srgbClr val="3A3A3A"/>
+                          </a:solidFill>
+                          <a:latin typeface="Montserrat"/>
+                        </a:rPr>
+                        <a:t>todas</a:t>
+                      </a:r>
+                    </a:p>
+                  </a:txBody>
+                  <a:tcPr marL="64008" marR="64008" marT="36576" marB="36576" anchor="ctr">
+                    <a:lnL w="6350">
+                      <a:solidFill>
+                        <a:srgbClr val="C9DED1"/>
+                      </a:solidFill>
+                    </a:lnL>
+                    <a:lnR w="6350">
+                      <a:solidFill>
+                        <a:srgbClr val="C9DED1"/>
+                      </a:solidFill>
+                    </a:lnR>
+                    <a:lnT w="6350">
+                      <a:solidFill>
+                        <a:srgbClr val="C9DED1"/>
+                      </a:solidFill>
+                    </a:lnT>
+                    <a:lnB w="6350">
+                      <a:solidFill>
+                        <a:srgbClr val="C9DED1"/>
+                      </a:solidFill>
+                    </a:lnB>
+                    <a:solidFill>
+                      <a:srgbClr val="FFFFFF"/>
+                    </a:solidFill>
+                  </a:tcPr>
+                </a:tc>
+                <a:tc>
+                  <a:txBody>
+                    <a:bodyPr/>
+                    <a:lstStyle/>
+                    <a:p>
+                      <a:pPr marL="0" indent="0" algn="l">
+                        <a:lnSpc>
+                          <a:spcPct val="100000"/>
+                        </a:lnSpc>
+                        <a:spcBef>
+                          <a:spcPts val="0"/>
+                        </a:spcBef>
+                        <a:spcAft>
+                          <a:spcPts val="0"/>
+                        </a:spcAft>
+                        <a:buNone/>
+                      </a:pPr>
+                      <a:r>
+                        <a:rPr lang="pt-BR" sz="1100" b="0" dirty="0">
+                          <a:solidFill>
+                            <a:srgbClr val="3A3A3A"/>
+                          </a:solidFill>
+                          <a:latin typeface="Montserrat"/>
+                        </a:rPr>
+                        <a:t>Holm nas primárias; BKY nas secundárias</a:t>
+                      </a:r>
+                    </a:p>
+                  </a:txBody>
+                  <a:tcPr marL="64008" marR="64008" marT="36576" marB="36576" anchor="ctr">
+                    <a:lnL w="6350">
+                      <a:solidFill>
+                        <a:srgbClr val="C9DED1"/>
+                      </a:solidFill>
+                    </a:lnL>
+                    <a:lnR w="6350">
+                      <a:solidFill>
+                        <a:srgbClr val="C9DED1"/>
+                      </a:solidFill>
+                    </a:lnR>
+                    <a:lnT w="6350">
+                      <a:solidFill>
+                        <a:srgbClr val="C9DED1"/>
+                      </a:solidFill>
+                    </a:lnT>
+                    <a:lnB w="6350">
+                      <a:solidFill>
+                        <a:srgbClr val="C9DED1"/>
+                      </a:solidFill>
+                    </a:lnB>
+                    <a:solidFill>
+                      <a:srgbClr val="FFFFFF"/>
+                    </a:solidFill>
+                  </a:tcPr>
+                </a:tc>
+                <a:tc>
+                  <a:txBody>
+                    <a:bodyPr/>
+                    <a:lstStyle/>
+                    <a:p>
+                      <a:pPr marL="0" indent="0" algn="l">
+                        <a:lnSpc>
+                          <a:spcPct val="100000"/>
+                        </a:lnSpc>
+                        <a:spcBef>
+                          <a:spcPts val="0"/>
+                        </a:spcBef>
+                        <a:spcAft>
+                          <a:spcPts val="0"/>
+                        </a:spcAft>
+                        <a:buNone/>
+                      </a:pPr>
+                      <a:r>
+                        <a:rPr lang="pt-BR" sz="1100" b="0" dirty="0">
+                          <a:solidFill>
+                            <a:srgbClr val="3A3A3A"/>
+                          </a:solidFill>
+                          <a:latin typeface="Montserrat"/>
+                        </a:rPr>
+                        <a:t>nenhuma primária rejeita zero, salvo o Y1 do P6</a:t>
+                      </a:r>
+                    </a:p>
+                  </a:txBody>
+                  <a:tcPr marL="64008" marR="64008" marT="36576" marB="36576" anchor="ctr">
+                    <a:lnL w="6350">
+                      <a:solidFill>
+                        <a:srgbClr val="C9DED1"/>
+                      </a:solidFill>
+                    </a:lnL>
+                    <a:lnR w="6350">
+                      <a:solidFill>
+                        <a:srgbClr val="C9DED1"/>
+                      </a:solidFill>
+                    </a:lnR>
+                    <a:lnT w="6350">
+                      <a:solidFill>
+                        <a:srgbClr val="C9DED1"/>
+                      </a:solidFill>
+                    </a:lnT>
+                    <a:lnB w="6350">
+                      <a:solidFill>
+                        <a:srgbClr val="C9DED1"/>
+                      </a:solidFill>
+                    </a:lnB>
+                    <a:solidFill>
+                      <a:srgbClr val="FFFFFF"/>
+                    </a:solidFill>
+                  </a:tcPr>
+                </a:tc>
+                <a:tc>
+                  <a:txBody>
+                    <a:bodyPr/>
+                    <a:lstStyle/>
+                    <a:p>
+                      <a:pPr marL="0" indent="0" algn="l">
+                        <a:lnSpc>
+                          <a:spcPct val="100000"/>
+                        </a:lnSpc>
+                        <a:spcBef>
+                          <a:spcPts val="0"/>
+                        </a:spcBef>
+                        <a:spcAft>
+                          <a:spcPts val="0"/>
+                        </a:spcAft>
+                        <a:buNone/>
+                      </a:pPr>
+                      <a:r>
+                        <a:rPr lang="pt-BR" sz="1100" b="0" dirty="0">
                           <a:solidFill>
                             <a:srgbClr val="3A3A3A"/>
                           </a:solidFill>
@@ -34132,7 +34234,7 @@
                       </a:solidFill>
                     </a:lnB>
                     <a:solidFill>
-                      <a:srgbClr val="F3F7F3"/>
+                      <a:srgbClr val="FFFFFF"/>
                     </a:solidFill>
                   </a:tcPr>
                 </a:tc>
@@ -34247,7 +34349,7 @@
                 </a:solidFill>
                 <a:latin typeface="Montserrat"/>
               </a:rPr>
-              <a:t>output/rdd_bolsa/N_estimativas.csv (doc 49, §3 e §7); P1_estimativas.csv (doc 57a); E8_resumo.json (E9); H_estimativas.csv e CA_estimativas.csv (doc 57h); doc 57, §3.</a:t>
+              <a:t>output/rdd_bolsa/N_estimativas.csv (doc 49, §3 e §7); P1_estimativas.csv (doc 57a); E8_resumo.json (E9); P1h_magnitudes.csv (doc 57i); H_estimativas.csv e CA_estimativas.csv (doc 57h); doc 57, §3.</a:t>
             </a:r>
           </a:p>
         </p:txBody>
@@ -35042,7 +35144,7 @@
         <p:spPr>
           <a:xfrm>
             <a:off x="292608" y="804672"/>
-            <a:ext cx="5660136" cy="2194560"/>
+            <a:ext cx="5660136" cy="1943100"/>
           </a:xfrm>
           <a:prstGeom prst="roundRect">
             <a:avLst>
@@ -35120,7 +35222,7 @@
         <p:spPr>
           <a:xfrm>
             <a:off x="6227064" y="804672"/>
-            <a:ext cx="5660136" cy="2194560"/>
+            <a:ext cx="5660136" cy="1943100"/>
           </a:xfrm>
           <a:prstGeom prst="roundRect">
             <a:avLst>
@@ -35197,8 +35299,8 @@
         </p:nvSpPr>
         <p:spPr>
           <a:xfrm>
-            <a:off x="292608" y="3273552"/>
-            <a:ext cx="5660136" cy="2194560"/>
+            <a:off x="292608" y="3022092"/>
+            <a:ext cx="5660136" cy="1943100"/>
           </a:xfrm>
           <a:prstGeom prst="roundRect">
             <a:avLst>
@@ -35275,8 +35377,8 @@
         </p:nvSpPr>
         <p:spPr>
           <a:xfrm>
-            <a:off x="6227064" y="3273552"/>
-            <a:ext cx="5660136" cy="2194560"/>
+            <a:off x="6227064" y="3022092"/>
+            <a:ext cx="5660136" cy="1943100"/>
           </a:xfrm>
           <a:prstGeom prst="roundRect">
             <a:avLst>
@@ -35340,7 +35442,7 @@
                 </a:solidFill>
                 <a:latin typeface="Montserrat"/>
               </a:rPr>
-              <a:t>Ciclo 3 com a competência 202703 publicada, completa e madura; pedidos do universo de inscritos e da folha de pagamento; H3 depois da auditoria.</a:t>
+              <a:t>Ciclo 3 com a competência 202703 publicada, completa e madura; pedidos do universo de inscritos e da folha de pagamento.</a:t>
             </a:r>
           </a:p>
         </p:txBody>

</xml_diff>

<commit_message>
Banca 2: cautelas da robustez (H3 pós-resultado) e das hipóteses sem linguagem de processo
Co-Authored-By: Claude Opus 5.5 <noreply@anthropic.com>
Claude-Session: https://claude.ai/code/session_011jPV4G6BtUxSX71P3Fzkr7
</commit_message>
<xml_diff>
--- a/output/apresentacao_banca2/slides_empiricos_banca2.pptx
+++ b/output/apresentacao_banca2/slides_empiricos_banca2.pptx
@@ -8811,7 +8811,7 @@
           <a:p>
             <a:r>
               <a:rPr lang="pt-BR" dirty="0"/>
-              <a:t>A banca 1 testava só a última seta. Testar cada seta explica um resultado nulo no fim da cadeia: se a bolsa pesa pouco perto do custo do lugar (H3), ela reordena candidatos entre vagas (H2) sem mudar quantas vagas preenchem (H1). A H4 pergunta se o médico que chega aumenta a capacidade ou só passa a ser registrado onde já estava. Cautela: H3 é a hipótese central (proposta do plano, delegada pelo autor e revisável por ele); H1 é o teste de consistência da cadeia.</a:t>
+              <a:t>A banca 1 testava só a última seta. Testar cada seta explica um resultado nulo no fim da cadeia: se a bolsa pesa pouco perto do custo do lugar (H3), ela reordena candidatos entre vagas (H2) sem mudar quantas vagas preenchem (H1). A H4 pergunta se o médico que chega aumenta a capacidade ou só passa a ser registrado onde já estava. Cautela: H3 é a hipótese central; H1 testa a consistência da cadeia.</a:t>
             </a:r>
           </a:p>
         </p:txBody>
@@ -9401,7 +9401,7 @@
           <a:p>
             <a:r>
               <a:rPr lang="pt-BR" dirty="0"/>
-              <a:t>Duas ressalvas da H1: com um só coeficiente do controle, N1 rejeitaria zero depois do Holm, mas o Wald rejeita essa restrição; e o IC honesto, com o M da regra de bolso, sai largo demais para informar. Ruptura de M̄ igual a 1 quer dizer que a conclusão aguenta violações de tendência do mesmo tamanho das vistas no pré. O apêndice traz cada teste com o número. A H3 é pós-resultado porque os coeficientes do M1 já eram conhecidos quando o protocolo 52b foi congelado. Cautela: As ressalvas estão na tela; nenhuma especificação foi escolhida depois de ver o resultado.</a:t>
+              <a:t>Duas ressalvas da H1: com um só coeficiente do controle, N1 rejeitaria zero depois do Holm, mas o Wald rejeita essa restrição; e o IC honesto, com o M da regra de bolso, sai largo demais para informar. Ruptura de M̄ igual a 1 quer dizer que a conclusão aguenta violações de tendência do mesmo tamanho das vistas no pré. O apêndice traz cada teste com o número. A H3 é pós-resultado porque os coeficientes do M1 já eram conhecidos quando o protocolo 52b foi congelado. Cautela: Especificações fixadas em protocolo antes de estimar; a H3 é pós-resultado e está rotulada assim.</a:t>
             </a:r>
           </a:p>
         </p:txBody>
@@ -17982,7 +17982,7 @@
                 </a:solidFill>
                 <a:latin typeface="Montserrat"/>
               </a:rPr>
-              <a:t>H3 é a hipótese central (proposta do plano, delegada pelo autor e revisável por ele); H1 é o teste de consistência da cadeia.</a:t>
+              <a:t>H3 é a hipótese central; H1 testa a consistência da cadeia.</a:t>
             </a:r>
           </a:p>
         </p:txBody>
@@ -27050,7 +27050,7 @@
                 </a:solidFill>
                 <a:latin typeface="Montserrat"/>
               </a:rPr>
-              <a:t>Robustez: as leituras resistem, com duas ressalvas declaradas</a:t>
+              <a:t>Robustez: as leituras resistem, com ressalvas declaradas</a:t>
             </a:r>
           </a:p>
         </p:txBody>
@@ -28064,7 +28064,7 @@
                 </a:solidFill>
                 <a:latin typeface="Montserrat"/>
               </a:rPr>
-              <a:t>As ressalvas estão na tela; nenhuma especificação foi escolhida depois de ver o resultado.</a:t>
+              <a:t>Especificações fixadas em protocolo antes de estimar; a H3 é pós-resultado e está rotulada assim.</a:t>
             </a:r>
           </a:p>
         </p:txBody>

</xml_diff>